<commit_message>
Session 1: remove handout-dependent activities, strip facilitator notes from slides
Removed (required printed worksheets/cards):
- Observer Round (required printed observation worksheet)
- Settings Gallery (required pre-printed setting cards)
- Design Decision Cards (required printed fill-in cards)
- Sort the Examples (required DIGITISED/DIGITAL cards per person)

Rewritten to use generic materials (phones, sticky notes, whiteboard):
- Sticky Note Audit (replaces Settings Gallery)
- Digital or Digitised? (Mentimeter poll, replaces card sort)
- Commitment Partner (phone reminder instead of printed card)
- The Gap (Mentimeter instead of folded paper)

Slides now only show participant-facing content. Facilitator notes
moved to the .docx guide and to a collapsible 'Facilitator notes'
section on the web page.

Activity count: 27 → 25

Co-Authored-By: Claude Opus 4.6 <noreply@anthropic.com>
</commit_message>
<xml_diff>
--- a/assets/downloads/Session-1-What-Is-Digital-Youth-Work.pptx
+++ b/assets/downloads/Session-1-What-Is-Digital-Youth-Work.pptx
@@ -38,8 +38,6 @@
     <p:sldId id="286" r:id="rId37"/>
     <p:sldId id="287" r:id="rId38"/>
     <p:sldId id="288" r:id="rId39"/>
-    <p:sldId id="289" r:id="rId40"/>
-    <p:sldId id="290" r:id="rId41"/>
   </p:sldIdLst>
   <p:sldSz cx="12191695" cy="6858000" type="screen4x3"/>
   <p:notesSz cx="6858000" cy="9144000"/>
@@ -3766,21 +3764,21 @@
         <p:spPr>
           <a:xfrm>
             <a:off x="731520" y="2560320"/>
-            <a:ext cx="10515600" cy="1828800"/>
-          </a:xfrm>
-          <a:prstGeom prst="rect">
-            <a:avLst/>
-          </a:prstGeom>
-          <a:noFill/>
-        </p:spPr>
-        <p:txBody>
-          <a:bodyPr wrap="square" lIns="0" rIns="0">
-            <a:spAutoFit/>
-          </a:bodyPr>
-          <a:lstStyle/>
-          <a:p>
-            <a:pPr algn="l">
-              <a:defRPr sz="1700" b="0">
+            <a:ext cx="10515600" cy="2743200"/>
+          </a:xfrm>
+          <a:prstGeom prst="rect">
+            <a:avLst/>
+          </a:prstGeom>
+          <a:noFill/>
+        </p:spPr>
+        <p:txBody>
+          <a:bodyPr wrap="square" lIns="0" rIns="0">
+            <a:spAutoFit/>
+          </a:bodyPr>
+          <a:lstStyle/>
+          <a:p>
+            <a:pPr algn="l">
+              <a:defRPr sz="1900" b="0">
                 <a:solidFill>
                   <a:srgbClr val="FFFFFF"/>
                 </a:solidFill>
@@ -3789,84 +3787,13 @@
             </a:pPr>
             <a:r>
               <a:t>Join a pre-made Kahoot quiz on your phones. No briefing — just play. Experience the timer, the leaderboard, the music, the pressure. Don't overthink it.</a:t>
-            </a:r>
-          </a:p>
-        </p:txBody>
-      </p:sp>
-      <p:sp>
-        <p:nvSpPr>
-          <p:cNvPr id="7" name="TextBox 6"/>
-          <p:cNvSpPr txBox="1"/>
-          <p:nvPr/>
-        </p:nvSpPr>
-        <p:spPr>
-          <a:xfrm>
-            <a:off x="731520" y="4023360"/>
-            <a:ext cx="10515600" cy="2286000"/>
-          </a:xfrm>
-          <a:prstGeom prst="rect">
-            <a:avLst/>
-          </a:prstGeom>
-          <a:noFill/>
-        </p:spPr>
-        <p:txBody>
-          <a:bodyPr wrap="square" lIns="0">
-            <a:spAutoFit/>
-          </a:bodyPr>
-          <a:lstStyle/>
-          <a:p>
-            <a:pPr>
-              <a:spcAft>
-                <a:spcPts val="800"/>
-              </a:spcAft>
-              <a:defRPr sz="1400">
-                <a:solidFill>
-                  <a:srgbClr val="B8B8D0"/>
-                </a:solidFill>
-                <a:latin typeface="Calibri"/>
-              </a:defRPr>
-            </a:pPr>
-            <a:r>
-              <a:t>→  Facilitator runs a 10-question Kahoot (topic: general knowledge or fun)</a:t>
-            </a:r>
-          </a:p>
-          <a:p>
-            <a:pPr>
-              <a:spcAft>
-                <a:spcPts val="800"/>
-              </a:spcAft>
-              <a:defRPr sz="1400">
-                <a:solidFill>
-                  <a:srgbClr val="B8B8D0"/>
-                </a:solidFill>
-                <a:latin typeface="Calibri"/>
-              </a:defRPr>
-            </a:pPr>
-            <a:r>
-              <a:t>→  Participants play on their phones as if they were young people</a:t>
-            </a:r>
-          </a:p>
-          <a:p>
-            <a:pPr>
-              <a:spcAft>
-                <a:spcPts val="800"/>
-              </a:spcAft>
-              <a:defRPr sz="1400">
-                <a:solidFill>
-                  <a:srgbClr val="B8B8D0"/>
-                </a:solidFill>
-                <a:latin typeface="Calibri"/>
-              </a:defRPr>
-            </a:pPr>
-            <a:r>
-              <a:t>→  No talking — just play the game as it comes</a:t>
             </a:r>
           </a:p>
         </p:txBody>
       </p:sp>
       <p:pic>
         <p:nvPicPr>
-          <p:cNvPr id="8" name="Picture 7" descr="logo.png"/>
+          <p:cNvPr id="7" name="Picture 6" descr="logo.png"/>
           <p:cNvPicPr>
             <a:picLocks noChangeAspect="1"/>
           </p:cNvPicPr>
@@ -3890,7 +3817,7 @@
       </p:pic>
       <p:sp>
         <p:nvSpPr>
-          <p:cNvPr id="9" name="TextBox 8"/>
+          <p:cNvPr id="8" name="TextBox 7"/>
           <p:cNvSpPr txBox="1"/>
           <p:nvPr/>
         </p:nvSpPr>
@@ -4060,7 +3987,7 @@
               </a:defRPr>
             </a:pPr>
             <a:r>
-              <a:t>Observer Round</a:t>
+              <a:t>What Just Happened?</a:t>
             </a:r>
           </a:p>
         </p:txBody>
@@ -4074,21 +4001,21 @@
         <p:spPr>
           <a:xfrm>
             <a:off x="731520" y="2103120"/>
-            <a:ext cx="10515600" cy="1828800"/>
-          </a:xfrm>
-          <a:prstGeom prst="rect">
-            <a:avLst/>
-          </a:prstGeom>
-          <a:noFill/>
-        </p:spPr>
-        <p:txBody>
-          <a:bodyPr wrap="square" lIns="0" rIns="0">
-            <a:spAutoFit/>
-          </a:bodyPr>
-          <a:lstStyle/>
-          <a:p>
-            <a:pPr algn="l">
-              <a:defRPr sz="1700" b="0">
+            <a:ext cx="10515600" cy="2743200"/>
+          </a:xfrm>
+          <a:prstGeom prst="rect">
+            <a:avLst/>
+          </a:prstGeom>
+          <a:noFill/>
+        </p:spPr>
+        <p:txBody>
+          <a:bodyPr wrap="square" lIns="0" rIns="0">
+            <a:spAutoFit/>
+          </a:bodyPr>
+          <a:lstStyle/>
+          <a:p>
+            <a:pPr algn="l">
+              <a:defRPr sz="1900" b="0">
                 <a:solidFill>
                   <a:srgbClr val="FFFFFF"/>
                 </a:solidFill>
@@ -4096,7 +4023,7 @@
               </a:defRPr>
             </a:pPr>
             <a:r>
-              <a:t>Half the group plays a shorter quiz (5 questions) while the other half silently watches. Observers use a worksheet: Who looks stressed? Who lights up? Who disengages? Who's first to answer? Who checks their phone between questions?</a:t>
+              <a:t>Sticky notes in two columns on the board: one thing that felt good, one thing that felt bad. Quick show of hands: who felt competitive? Who felt stressed? Who checked out?</a:t>
             </a:r>
           </a:p>
         </p:txBody>
@@ -4297,7 +4224,7 @@
               </a:defRPr>
             </a:pPr>
             <a:r>
-              <a:t>What Just Happened?</a:t>
+              <a:t>Change One Thing</a:t>
             </a:r>
           </a:p>
         </p:txBody>
@@ -4311,21 +4238,57 @@
         <p:spPr>
           <a:xfrm>
             <a:off x="731520" y="2103120"/>
-            <a:ext cx="10515600" cy="1828800"/>
-          </a:xfrm>
-          <a:prstGeom prst="rect">
-            <a:avLst/>
-          </a:prstGeom>
-          <a:noFill/>
-        </p:spPr>
-        <p:txBody>
-          <a:bodyPr wrap="square" lIns="0" rIns="0">
-            <a:spAutoFit/>
-          </a:bodyPr>
-          <a:lstStyle/>
-          <a:p>
-            <a:pPr algn="l">
-              <a:defRPr sz="1700" b="0">
+            <a:ext cx="10515600" cy="365760"/>
+          </a:xfrm>
+          <a:prstGeom prst="rect">
+            <a:avLst/>
+          </a:prstGeom>
+          <a:noFill/>
+        </p:spPr>
+        <p:txBody>
+          <a:bodyPr wrap="square" lIns="0" rIns="0">
+            <a:spAutoFit/>
+          </a:bodyPr>
+          <a:lstStyle/>
+          <a:p>
+            <a:pPr algn="l">
+              <a:defRPr sz="1400" b="1">
+                <a:solidFill>
+                  <a:srgbClr val="E91E8C"/>
+                </a:solidFill>
+                <a:latin typeface="Calibri"/>
+              </a:defRPr>
+            </a:pPr>
+            <a:r>
+              <a:t>🛠  Kahoot</a:t>
+            </a:r>
+          </a:p>
+        </p:txBody>
+      </p:sp>
+      <p:sp>
+        <p:nvSpPr>
+          <p:cNvPr id="6" name="TextBox 5"/>
+          <p:cNvSpPr txBox="1"/>
+          <p:nvPr/>
+        </p:nvSpPr>
+        <p:spPr>
+          <a:xfrm>
+            <a:off x="731520" y="2560320"/>
+            <a:ext cx="10515600" cy="2743200"/>
+          </a:xfrm>
+          <a:prstGeom prst="rect">
+            <a:avLst/>
+          </a:prstGeom>
+          <a:noFill/>
+        </p:spPr>
+        <p:txBody>
+          <a:bodyPr wrap="square" lIns="0" rIns="0">
+            <a:spAutoFit/>
+          </a:bodyPr>
+          <a:lstStyle/>
+          <a:p>
+            <a:pPr algn="l">
+              <a:defRPr sz="1900" b="0">
                 <a:solidFill>
                   <a:srgbClr val="FFFFFF"/>
                 </a:solidFill>
@@ -4333,94 +4296,7 @@
               </a:defRPr>
             </a:pPr>
             <a:r>
-              <a:t>Debrief the experience before changing anything.</a:t>
-            </a:r>
-          </a:p>
-        </p:txBody>
-      </p:sp>
-      <p:sp>
-        <p:nvSpPr>
-          <p:cNvPr id="6" name="TextBox 5"/>
-          <p:cNvSpPr txBox="1"/>
-          <p:nvPr/>
-        </p:nvSpPr>
-        <p:spPr>
-          <a:xfrm>
-            <a:off x="731520" y="3566160"/>
-            <a:ext cx="10515600" cy="2286000"/>
-          </a:xfrm>
-          <a:prstGeom prst="rect">
-            <a:avLst/>
-          </a:prstGeom>
-          <a:noFill/>
-        </p:spPr>
-        <p:txBody>
-          <a:bodyPr wrap="square" lIns="0">
-            <a:spAutoFit/>
-          </a:bodyPr>
-          <a:lstStyle/>
-          <a:p>
-            <a:pPr>
-              <a:spcAft>
-                <a:spcPts val="800"/>
-              </a:spcAft>
-              <a:defRPr sz="1400">
-                <a:solidFill>
-                  <a:srgbClr val="B8B8D0"/>
-                </a:solidFill>
-                <a:latin typeface="Calibri"/>
-              </a:defRPr>
-            </a:pPr>
-            <a:r>
-              <a:t>→  Show of hands: Who felt competitive? Who felt stressed? Who stopped caring?</a:t>
-            </a:r>
-          </a:p>
-          <a:p>
-            <a:pPr>
-              <a:spcAft>
-                <a:spcPts val="800"/>
-              </a:spcAft>
-              <a:defRPr sz="1400">
-                <a:solidFill>
-                  <a:srgbClr val="B8B8D0"/>
-                </a:solidFill>
-                <a:latin typeface="Calibri"/>
-              </a:defRPr>
-            </a:pPr>
-            <a:r>
-              <a:t>→  On sticky notes: one thing that felt good, one thing that felt bad</a:t>
-            </a:r>
-          </a:p>
-          <a:p>
-            <a:pPr>
-              <a:spcAft>
-                <a:spcPts val="800"/>
-              </a:spcAft>
-              <a:defRPr sz="1400">
-                <a:solidFill>
-                  <a:srgbClr val="B8B8D0"/>
-                </a:solidFill>
-                <a:latin typeface="Calibri"/>
-              </a:defRPr>
-            </a:pPr>
-            <a:r>
-              <a:t>→  Stick them on the board in two columns. Read a few out.</a:t>
-            </a:r>
-          </a:p>
-          <a:p>
-            <a:pPr>
-              <a:spcAft>
-                <a:spcPts val="800"/>
-              </a:spcAft>
-              <a:defRPr sz="1400">
-                <a:solidFill>
-                  <a:srgbClr val="B8B8D0"/>
-                </a:solidFill>
-                <a:latin typeface="Calibri"/>
-              </a:defRPr>
-            </a:pPr>
-            <a:r>
-              <a:t>→  Observers share what they saw — not what players said, what they saw</a:t>
+              <a:t>In pairs, pick ONE setting to change and re-run part of the quiz. Options: remove the timer / hide the leaderboard / enable anonymous answers / team mode / remove the music.</a:t>
             </a:r>
           </a:p>
         </p:txBody>
@@ -4621,7 +4497,7 @@
               </a:defRPr>
             </a:pPr>
             <a:r>
-              <a:t>Change One Thing</a:t>
+              <a:t>The Anonymous Round</a:t>
             </a:r>
           </a:p>
         </p:txBody>
@@ -4671,21 +4547,21 @@
         <p:spPr>
           <a:xfrm>
             <a:off x="731520" y="2560320"/>
-            <a:ext cx="10515600" cy="1828800"/>
-          </a:xfrm>
-          <a:prstGeom prst="rect">
-            <a:avLst/>
-          </a:prstGeom>
-          <a:noFill/>
-        </p:spPr>
-        <p:txBody>
-          <a:bodyPr wrap="square" lIns="0" rIns="0">
-            <a:spAutoFit/>
-          </a:bodyPr>
-          <a:lstStyle/>
-          <a:p>
-            <a:pPr algn="l">
-              <a:defRPr sz="1700" b="0">
+            <a:ext cx="10515600" cy="2743200"/>
+          </a:xfrm>
+          <a:prstGeom prst="rect">
+            <a:avLst/>
+          </a:prstGeom>
+          <a:noFill/>
+        </p:spPr>
+        <p:txBody>
+          <a:bodyPr wrap="square" lIns="0" rIns="0">
+            <a:spAutoFit/>
+          </a:bodyPr>
+          <a:lstStyle/>
+          <a:p>
+            <a:pPr algn="l">
+              <a:defRPr sz="1900" b="0">
                 <a:solidFill>
                   <a:srgbClr val="FFFFFF"/>
                 </a:solidFill>
@@ -4693,85 +4569,14 @@
               </a:defRPr>
             </a:pPr>
             <a:r>
-              <a:t>In pairs, pick ONE setting to change and re-run part of the quiz.</a:t>
-            </a:r>
-          </a:p>
-        </p:txBody>
-      </p:sp>
-      <p:sp>
-        <p:nvSpPr>
-          <p:cNvPr id="7" name="TextBox 6"/>
-          <p:cNvSpPr txBox="1"/>
-          <p:nvPr/>
-        </p:nvSpPr>
-        <p:spPr>
-          <a:xfrm>
-            <a:off x="731520" y="4023360"/>
-            <a:ext cx="10515600" cy="2286000"/>
-          </a:xfrm>
-          <a:prstGeom prst="rect">
-            <a:avLst/>
-          </a:prstGeom>
-          <a:noFill/>
-        </p:spPr>
-        <p:txBody>
-          <a:bodyPr wrap="square" lIns="0">
-            <a:spAutoFit/>
-          </a:bodyPr>
-          <a:lstStyle/>
-          <a:p>
-            <a:pPr>
-              <a:spcAft>
-                <a:spcPts val="800"/>
-              </a:spcAft>
-              <a:defRPr sz="1400">
-                <a:solidFill>
-                  <a:srgbClr val="B8B8D0"/>
-                </a:solidFill>
-                <a:latin typeface="Calibri"/>
-              </a:defRPr>
-            </a:pPr>
-            <a:r>
-              <a:t>→  Options: remove the timer / hide the leaderboard / enable anonymous answers / team mode / remove the music</a:t>
-            </a:r>
-          </a:p>
-          <a:p>
-            <a:pPr>
-              <a:spcAft>
-                <a:spcPts val="800"/>
-              </a:spcAft>
-              <a:defRPr sz="1400">
-                <a:solidFill>
-                  <a:srgbClr val="B8B8D0"/>
-                </a:solidFill>
-                <a:latin typeface="Calibri"/>
-              </a:defRPr>
-            </a:pPr>
-            <a:r>
-              <a:t>→  Facilitator sets up a shorter quiz with the change</a:t>
-            </a:r>
-          </a:p>
-          <a:p>
-            <a:pPr>
-              <a:spcAft>
-                <a:spcPts val="800"/>
-              </a:spcAft>
-              <a:defRPr sz="1400">
-                <a:solidFill>
-                  <a:srgbClr val="B8B8D0"/>
-                </a:solidFill>
-                <a:latin typeface="Calibri"/>
-              </a:defRPr>
-            </a:pPr>
-            <a:r>
-              <a:t>→  Re-run. What's different? Is it better or worse? For who?</a:t>
+              <a:t>Re-run the quiz with anonymous nicknames (no real names on the leaderboard). Who contributes now who didn't before? Who goes quieter? Share what you noticed.</a:t>
             </a:r>
           </a:p>
         </p:txBody>
       </p:sp>
       <p:pic>
         <p:nvPicPr>
-          <p:cNvPr id="8" name="Picture 7" descr="logo.png"/>
+          <p:cNvPr id="7" name="Picture 6" descr="logo.png"/>
           <p:cNvPicPr>
             <a:picLocks noChangeAspect="1"/>
           </p:cNvPicPr>
@@ -4795,7 +4600,7 @@
       </p:pic>
       <p:sp>
         <p:nvSpPr>
-          <p:cNvPr id="9" name="TextBox 8"/>
+          <p:cNvPr id="8" name="TextBox 7"/>
           <p:cNvSpPr txBox="1"/>
           <p:nvPr/>
         </p:nvSpPr>
@@ -4965,7 +4770,7 @@
               </a:defRPr>
             </a:pPr>
             <a:r>
-              <a:t>The Anonymous Round</a:t>
+              <a:t>Sticky Note Audit</a:t>
             </a:r>
           </a:p>
         </p:txBody>
@@ -4979,57 +4784,21 @@
         <p:spPr>
           <a:xfrm>
             <a:off x="731520" y="2103120"/>
-            <a:ext cx="10515600" cy="365760"/>
-          </a:xfrm>
-          <a:prstGeom prst="rect">
-            <a:avLst/>
-          </a:prstGeom>
-          <a:noFill/>
-        </p:spPr>
-        <p:txBody>
-          <a:bodyPr wrap="square" lIns="0" rIns="0">
-            <a:spAutoFit/>
-          </a:bodyPr>
-          <a:lstStyle/>
-          <a:p>
-            <a:pPr algn="l">
-              <a:defRPr sz="1400" b="1">
-                <a:solidFill>
-                  <a:srgbClr val="E91E8C"/>
-                </a:solidFill>
-                <a:latin typeface="Calibri"/>
-              </a:defRPr>
-            </a:pPr>
-            <a:r>
-              <a:t>🛠  Kahoot</a:t>
-            </a:r>
-          </a:p>
-        </p:txBody>
-      </p:sp>
-      <p:sp>
-        <p:nvSpPr>
-          <p:cNvPr id="6" name="TextBox 5"/>
-          <p:cNvSpPr txBox="1"/>
-          <p:nvPr/>
-        </p:nvSpPr>
-        <p:spPr>
-          <a:xfrm>
-            <a:off x="731520" y="2560320"/>
-            <a:ext cx="10515600" cy="1828800"/>
-          </a:xfrm>
-          <a:prstGeom prst="rect">
-            <a:avLst/>
-          </a:prstGeom>
-          <a:noFill/>
-        </p:spPr>
-        <p:txBody>
-          <a:bodyPr wrap="square" lIns="0" rIns="0">
-            <a:spAutoFit/>
-          </a:bodyPr>
-          <a:lstStyle/>
-          <a:p>
-            <a:pPr algn="l">
-              <a:defRPr sz="1700" b="0">
+            <a:ext cx="10515600" cy="2743200"/>
+          </a:xfrm>
+          <a:prstGeom prst="rect">
+            <a:avLst/>
+          </a:prstGeom>
+          <a:noFill/>
+        </p:spPr>
+        <p:txBody>
+          <a:bodyPr wrap="square" lIns="0" rIns="0">
+            <a:spAutoFit/>
+          </a:bodyPr>
+          <a:lstStyle/>
+          <a:p>
+            <a:pPr algn="l">
+              <a:defRPr sz="1900" b="0">
                 <a:solidFill>
                   <a:srgbClr val="FFFFFF"/>
                 </a:solidFill>
@@ -5037,14 +4806,14 @@
               </a:defRPr>
             </a:pPr>
             <a:r>
-              <a:t>Re-run with anonymous nicknames (no real names on the leaderboard). Does anything shift? Who contributes now who didn't before? Who goes quieter? Note it down.</a:t>
+              <a:t>On the whiteboard, write each Kahoot setting across the top (timer, leaderboard, music, team mode, anonymous). In pairs, walk up and add a sticky note under each one: 'What this changes for a young person.' Read the wall aloud as a group.</a:t>
             </a:r>
           </a:p>
         </p:txBody>
       </p:sp>
       <p:pic>
         <p:nvPicPr>
-          <p:cNvPr id="7" name="Picture 6" descr="logo.png"/>
+          <p:cNvPr id="6" name="Picture 5" descr="logo.png"/>
           <p:cNvPicPr>
             <a:picLocks noChangeAspect="1"/>
           </p:cNvPicPr>
@@ -5068,7 +4837,7 @@
       </p:pic>
       <p:sp>
         <p:nvSpPr>
-          <p:cNvPr id="8" name="TextBox 7"/>
+          <p:cNvPr id="7" name="TextBox 6"/>
           <p:cNvSpPr txBox="1"/>
           <p:nvPr/>
         </p:nvSpPr>
@@ -5238,7 +5007,7 @@
               </a:defRPr>
             </a:pPr>
             <a:r>
-              <a:t>Settings Gallery</a:t>
+              <a:t>Second Pass — Swap</a:t>
             </a:r>
           </a:p>
         </p:txBody>
@@ -5252,21 +5021,57 @@
         <p:spPr>
           <a:xfrm>
             <a:off x="731520" y="2103120"/>
-            <a:ext cx="10515600" cy="1828800"/>
-          </a:xfrm>
-          <a:prstGeom prst="rect">
-            <a:avLst/>
-          </a:prstGeom>
-          <a:noFill/>
-        </p:spPr>
-        <p:txBody>
-          <a:bodyPr wrap="square" lIns="0" rIns="0">
-            <a:spAutoFit/>
-          </a:bodyPr>
-          <a:lstStyle/>
-          <a:p>
-            <a:pPr algn="l">
-              <a:defRPr sz="1700" b="0">
+            <a:ext cx="10515600" cy="365760"/>
+          </a:xfrm>
+          <a:prstGeom prst="rect">
+            <a:avLst/>
+          </a:prstGeom>
+          <a:noFill/>
+        </p:spPr>
+        <p:txBody>
+          <a:bodyPr wrap="square" lIns="0" rIns="0">
+            <a:spAutoFit/>
+          </a:bodyPr>
+          <a:lstStyle/>
+          <a:p>
+            <a:pPr algn="l">
+              <a:defRPr sz="1400" b="1">
+                <a:solidFill>
+                  <a:srgbClr val="E91E8C"/>
+                </a:solidFill>
+                <a:latin typeface="Calibri"/>
+              </a:defRPr>
+            </a:pPr>
+            <a:r>
+              <a:t>🛠  Kahoot</a:t>
+            </a:r>
+          </a:p>
+        </p:txBody>
+      </p:sp>
+      <p:sp>
+        <p:nvSpPr>
+          <p:cNvPr id="6" name="TextBox 5"/>
+          <p:cNvSpPr txBox="1"/>
+          <p:nvPr/>
+        </p:nvSpPr>
+        <p:spPr>
+          <a:xfrm>
+            <a:off x="731520" y="2560320"/>
+            <a:ext cx="10515600" cy="2743200"/>
+          </a:xfrm>
+          <a:prstGeom prst="rect">
+            <a:avLst/>
+          </a:prstGeom>
+          <a:noFill/>
+        </p:spPr>
+        <p:txBody>
+          <a:bodyPr wrap="square" lIns="0" rIns="0">
+            <a:spAutoFit/>
+          </a:bodyPr>
+          <a:lstStyle/>
+          <a:p>
+            <a:pPr algn="l">
+              <a:defRPr sz="1900" b="0">
                 <a:solidFill>
                   <a:srgbClr val="FFFFFF"/>
                 </a:solidFill>
@@ -5274,14 +5079,14 @@
               </a:defRPr>
             </a:pPr>
             <a:r>
-              <a:t>Pin a card on the wall for each Kahoot setting (timer, leaderboard, music, team mode, anonymous, chat, skip-allowed). In pairs, walk round and add a sticky note to each: 'What this changes for the young person.' Read the wall as a group.</a:t>
+              <a:t>Swap roles — the loud ones step back, the quiet ones lead. Change a different setting. What shifts? What's different when the dynamic changes, not just the tool?</a:t>
             </a:r>
           </a:p>
         </p:txBody>
       </p:sp>
       <p:pic>
         <p:nvPicPr>
-          <p:cNvPr id="6" name="Picture 5" descr="logo.png"/>
+          <p:cNvPr id="7" name="Picture 6" descr="logo.png"/>
           <p:cNvPicPr>
             <a:picLocks noChangeAspect="1"/>
           </p:cNvPicPr>
@@ -5305,7 +5110,7 @@
       </p:pic>
       <p:sp>
         <p:nvSpPr>
-          <p:cNvPr id="7" name="TextBox 6"/>
+          <p:cNvPr id="8" name="TextBox 7"/>
           <p:cNvSpPr txBox="1"/>
           <p:nvPr/>
         </p:nvSpPr>
@@ -5353,7 +5158,7 @@
     <p:bg>
       <p:bgPr>
         <a:solidFill>
-          <a:srgbClr val="161627"/>
+          <a:srgbClr val="0D0D1A"/>
         </a:solidFill>
         <a:effectLst/>
       </p:bgPr>
@@ -5374,13 +5179,13 @@
         <p:spPr>
           <a:xfrm>
             <a:off x="0" y="0"/>
-            <a:ext cx="12191695" cy="109728"/>
+            <a:ext cx="228600" cy="6858000"/>
           </a:xfrm>
           <a:prstGeom prst="rect">
             <a:avLst/>
           </a:prstGeom>
           <a:solidFill>
-            <a:srgbClr val="E91E8C"/>
+            <a:srgbClr val="7B61FF"/>
           </a:solidFill>
           <a:ln>
             <a:noFill/>
@@ -5416,7 +5221,7 @@
         </p:nvSpPr>
         <p:spPr>
           <a:xfrm>
-            <a:off x="731520" y="365760"/>
+            <a:off x="731520" y="411480"/>
             <a:ext cx="5486400" cy="365760"/>
           </a:xfrm>
           <a:prstGeom prst="rect">
@@ -5431,15 +5236,15 @@
           <a:lstStyle/>
           <a:p>
             <a:pPr algn="l">
-              <a:defRPr sz="1200" b="1">
-                <a:solidFill>
-                  <a:srgbClr val="E91E8C"/>
-                </a:solidFill>
-                <a:latin typeface="Calibri"/>
-              </a:defRPr>
-            </a:pPr>
-            <a:r>
-              <a:t>ACTIVITY</a:t>
+              <a:defRPr sz="1400" b="1">
+                <a:solidFill>
+                  <a:srgbClr val="7B61FF"/>
+                </a:solidFill>
+                <a:latin typeface="Calibri"/>
+              </a:defRPr>
+            </a:pPr>
+            <a:r>
+              <a:t>KEY IDEAS</a:t>
             </a:r>
           </a:p>
         </p:txBody>
@@ -5452,22 +5257,58 @@
         </p:nvSpPr>
         <p:spPr>
           <a:xfrm>
-            <a:off x="731520" y="914400"/>
-            <a:ext cx="10515600" cy="1097280"/>
-          </a:xfrm>
-          <a:prstGeom prst="rect">
-            <a:avLst/>
-          </a:prstGeom>
-          <a:noFill/>
-        </p:spPr>
-        <p:txBody>
-          <a:bodyPr wrap="square" lIns="0" rIns="0">
-            <a:spAutoFit/>
-          </a:bodyPr>
-          <a:lstStyle/>
-          <a:p>
-            <a:pPr algn="l">
-              <a:defRPr sz="3400" b="1">
+            <a:off x="731520" y="868680"/>
+            <a:ext cx="5486400" cy="365760"/>
+          </a:xfrm>
+          <a:prstGeom prst="rect">
+            <a:avLst/>
+          </a:prstGeom>
+          <a:noFill/>
+        </p:spPr>
+        <p:txBody>
+          <a:bodyPr wrap="square" lIns="0" rIns="0">
+            <a:spAutoFit/>
+          </a:bodyPr>
+          <a:lstStyle/>
+          <a:p>
+            <a:pPr algn="l">
+              <a:defRPr sz="1200" b="0">
+                <a:solidFill>
+                  <a:srgbClr val="7B7B96"/>
+                </a:solidFill>
+                <a:latin typeface="Calibri"/>
+              </a:defRPr>
+            </a:pPr>
+            <a:r>
+              <a:t>75 – 95 min</a:t>
+            </a:r>
+          </a:p>
+        </p:txBody>
+      </p:sp>
+      <p:sp>
+        <p:nvSpPr>
+          <p:cNvPr id="5" name="TextBox 4"/>
+          <p:cNvSpPr txBox="1"/>
+          <p:nvPr/>
+        </p:nvSpPr>
+        <p:spPr>
+          <a:xfrm>
+            <a:off x="731520" y="1828800"/>
+            <a:ext cx="10515600" cy="1371600"/>
+          </a:xfrm>
+          <a:prstGeom prst="rect">
+            <a:avLst/>
+          </a:prstGeom>
+          <a:noFill/>
+        </p:spPr>
+        <p:txBody>
+          <a:bodyPr wrap="square" lIns="0" rIns="0">
+            <a:spAutoFit/>
+          </a:bodyPr>
+          <a:lstStyle/>
+          <a:p>
+            <a:pPr algn="l">
+              <a:defRPr sz="3800" b="1">
                 <a:solidFill>
                   <a:srgbClr val="FFFFFF"/>
                 </a:solidFill>
@@ -5475,35 +5316,38 @@
               </a:defRPr>
             </a:pPr>
             <a:r>
-              <a:t>Design Decision Cards</a:t>
-            </a:r>
-          </a:p>
-        </p:txBody>
-      </p:sp>
-      <p:sp>
-        <p:nvSpPr>
-          <p:cNvPr id="5" name="TextBox 4"/>
-          <p:cNvSpPr txBox="1"/>
-          <p:nvPr/>
-        </p:nvSpPr>
-        <p:spPr>
-          <a:xfrm>
-            <a:off x="731520" y="2103120"/>
-            <a:ext cx="10515600" cy="1828800"/>
-          </a:xfrm>
-          <a:prstGeom prst="rect">
-            <a:avLst/>
-          </a:prstGeom>
-          <a:noFill/>
-        </p:spPr>
-        <p:txBody>
-          <a:bodyPr wrap="square" lIns="0" rIns="0">
-            <a:spAutoFit/>
-          </a:bodyPr>
-          <a:lstStyle/>
-          <a:p>
-            <a:pPr algn="l">
-              <a:defRPr sz="1700" b="0">
+              <a:t>Digital vs Digitised Youth Work</a:t>
+            </a:r>
+          </a:p>
+        </p:txBody>
+      </p:sp>
+      <p:sp>
+        <p:nvSpPr>
+          <p:cNvPr id="6" name="TextBox 5"/>
+          <p:cNvSpPr txBox="1"/>
+          <p:nvPr/>
+        </p:nvSpPr>
+        <p:spPr>
+          <a:xfrm>
+            <a:off x="731520" y="3200400"/>
+            <a:ext cx="10515600" cy="3200400"/>
+          </a:xfrm>
+          <a:prstGeom prst="rect">
+            <a:avLst/>
+          </a:prstGeom>
+          <a:noFill/>
+        </p:spPr>
+        <p:txBody>
+          <a:bodyPr wrap="square" lIns="0">
+            <a:spAutoFit/>
+          </a:bodyPr>
+          <a:lstStyle/>
+          <a:p>
+            <a:pPr>
+              <a:spcAft>
+                <a:spcPts val="800"/>
+              </a:spcAft>
+              <a:defRPr sz="1700">
                 <a:solidFill>
                   <a:srgbClr val="FFFFFF"/>
                 </a:solidFill>
@@ -5511,35 +5355,43 @@
               </a:defRPr>
             </a:pPr>
             <a:r>
-              <a:t>Each pair fills in a card: 'We changed ___ because ___. The effect was ___. For a young person who ___ this would mean ___.' Share back to the group.</a:t>
-            </a:r>
-          </a:p>
-        </p:txBody>
-      </p:sp>
-      <p:pic>
-        <p:nvPicPr>
-          <p:cNvPr id="6" name="Picture 5" descr="logo.png"/>
-          <p:cNvPicPr>
-            <a:picLocks noChangeAspect="1"/>
-          </p:cNvPicPr>
-          <p:nvPr/>
-        </p:nvPicPr>
-        <p:blipFill>
-          <a:blip r:embed="rId2"/>
-          <a:stretch>
-            <a:fillRect/>
-          </a:stretch>
-        </p:blipFill>
-        <p:spPr>
-          <a:xfrm>
-            <a:off x="10515600" y="6355080"/>
-            <a:ext cx="1180586" cy="274320"/>
-          </a:xfrm>
-          <a:prstGeom prst="rect">
-            <a:avLst/>
-          </a:prstGeom>
-        </p:spPr>
-      </p:pic>
+              <a:t>•  Digitised = taking what you already do and putting it on a screen (paper form → Google Form)</a:t>
+            </a:r>
+          </a:p>
+          <a:p>
+            <a:pPr>
+              <a:spcAft>
+                <a:spcPts val="800"/>
+              </a:spcAft>
+              <a:defRPr sz="1700">
+                <a:solidFill>
+                  <a:srgbClr val="FFFFFF"/>
+                </a:solidFill>
+                <a:latin typeface="Calibri"/>
+              </a:defRPr>
+            </a:pPr>
+            <a:r>
+              <a:t>•  Digital = designing an experience that only works because it's online (anonymous polling, real-time collaboration, adaptive difficulty)</a:t>
+            </a:r>
+          </a:p>
+          <a:p>
+            <a:pPr>
+              <a:spcAft>
+                <a:spcPts val="800"/>
+              </a:spcAft>
+              <a:defRPr sz="1700">
+                <a:solidFill>
+                  <a:srgbClr val="FFFFFF"/>
+                </a:solidFill>
+                <a:latin typeface="Calibri"/>
+              </a:defRPr>
+            </a:pPr>
+            <a:r>
+              <a:t>•  The environment IS the practice — every setting (timer, names, chat, scores) is a youth work decision you're making for the young person</a:t>
+            </a:r>
+          </a:p>
+        </p:txBody>
+      </p:sp>
       <p:sp>
         <p:nvSpPr>
           <p:cNvPr id="7" name="TextBox 6"/>
@@ -5571,7 +5423,7 @@
               </a:defRPr>
             </a:pPr>
             <a:r>
-              <a:t>Session 1  ·  ACTIVITY</a:t>
+              <a:t>Robocode × LIA  ·  Digital Youth Work CPD  ·  Session 1 of 6</a:t>
             </a:r>
           </a:p>
         </p:txBody>
@@ -5617,7 +5469,7 @@
             <a:avLst/>
           </a:prstGeom>
           <a:solidFill>
-            <a:srgbClr val="E91E8C"/>
+            <a:srgbClr val="7B61FF"/>
           </a:solidFill>
           <a:ln>
             <a:noFill/>
@@ -5670,13 +5522,13 @@
             <a:pPr algn="l">
               <a:defRPr sz="1200" b="1">
                 <a:solidFill>
-                  <a:srgbClr val="E91E8C"/>
-                </a:solidFill>
-                <a:latin typeface="Calibri"/>
-              </a:defRPr>
-            </a:pPr>
-            <a:r>
-              <a:t>ACTIVITY</a:t>
+                  <a:srgbClr val="7B61FF"/>
+                </a:solidFill>
+                <a:latin typeface="Calibri"/>
+              </a:defRPr>
+            </a:pPr>
+            <a:r>
+              <a:t>KEY IDEAS</a:t>
             </a:r>
           </a:p>
         </p:txBody>
@@ -5712,7 +5564,7 @@
               </a:defRPr>
             </a:pPr>
             <a:r>
-              <a:t>Second Pass — Swap</a:t>
+              <a:t>Digital or Digitised?</a:t>
             </a:r>
           </a:p>
         </p:txBody>
@@ -5748,7 +5600,7 @@
               </a:defRPr>
             </a:pPr>
             <a:r>
-              <a:t>🛠  Kahoot</a:t>
+              <a:t>🛠  Mentimeter</a:t>
             </a:r>
           </a:p>
         </p:txBody>
@@ -5762,21 +5614,21 @@
         <p:spPr>
           <a:xfrm>
             <a:off x="731520" y="2560320"/>
-            <a:ext cx="10515600" cy="1828800"/>
-          </a:xfrm>
-          <a:prstGeom prst="rect">
-            <a:avLst/>
-          </a:prstGeom>
-          <a:noFill/>
-        </p:spPr>
-        <p:txBody>
-          <a:bodyPr wrap="square" lIns="0" rIns="0">
-            <a:spAutoFit/>
-          </a:bodyPr>
-          <a:lstStyle/>
-          <a:p>
-            <a:pPr algn="l">
-              <a:defRPr sz="1700" b="0">
+            <a:ext cx="10515600" cy="2743200"/>
+          </a:xfrm>
+          <a:prstGeom prst="rect">
+            <a:avLst/>
+          </a:prstGeom>
+          <a:noFill/>
+        </p:spPr>
+        <p:txBody>
+          <a:bodyPr wrap="square" lIns="0" rIns="0">
+            <a:spAutoFit/>
+          </a:bodyPr>
+          <a:lstStyle/>
+          <a:p>
+            <a:pPr algn="l">
+              <a:defRPr sz="1900" b="0">
                 <a:solidFill>
                   <a:srgbClr val="FFFFFF"/>
                 </a:solidFill>
@@ -5784,7 +5636,7 @@
               </a:defRPr>
             </a:pPr>
             <a:r>
-              <a:t>Observers now play; players now observe. Different setting changed. Observers: what do you notice now that you missed when you were playing? Players: what's different knowing someone is watching?</a:t>
+              <a:t>8 examples appear on screen one at a time. Vote live: DIGITAL or DIGITISED. See the split. Where the room disagrees, that's the conversation.</a:t>
             </a:r>
           </a:p>
         </p:txBody>
@@ -5844,7 +5696,7 @@
               </a:defRPr>
             </a:pPr>
             <a:r>
-              <a:t>Session 1  ·  ACTIVITY</a:t>
+              <a:t>Session 1  ·  KEY IDEAS</a:t>
             </a:r>
           </a:p>
         </p:txBody>
@@ -5863,7 +5715,7 @@
     <p:bg>
       <p:bgPr>
         <a:solidFill>
-          <a:srgbClr val="0D0D1A"/>
+          <a:srgbClr val="161627"/>
         </a:solidFill>
         <a:effectLst/>
       </p:bgPr>
@@ -5884,7 +5736,7 @@
         <p:spPr>
           <a:xfrm>
             <a:off x="0" y="0"/>
-            <a:ext cx="228600" cy="6858000"/>
+            <a:ext cx="12191695" cy="109728"/>
           </a:xfrm>
           <a:prstGeom prst="rect">
             <a:avLst/>
@@ -5926,7 +5778,7 @@
         </p:nvSpPr>
         <p:spPr>
           <a:xfrm>
-            <a:off x="731520" y="411480"/>
+            <a:off x="731520" y="365760"/>
             <a:ext cx="5486400" cy="365760"/>
           </a:xfrm>
           <a:prstGeom prst="rect">
@@ -5941,7 +5793,7 @@
           <a:lstStyle/>
           <a:p>
             <a:pPr algn="l">
-              <a:defRPr sz="1400" b="1">
+              <a:defRPr sz="1200" b="1">
                 <a:solidFill>
                   <a:srgbClr val="7B61FF"/>
                 </a:solidFill>
@@ -5962,30 +5814,30 @@
         </p:nvSpPr>
         <p:spPr>
           <a:xfrm>
-            <a:off x="731520" y="868680"/>
-            <a:ext cx="5486400" cy="365760"/>
-          </a:xfrm>
-          <a:prstGeom prst="rect">
-            <a:avLst/>
-          </a:prstGeom>
-          <a:noFill/>
-        </p:spPr>
-        <p:txBody>
-          <a:bodyPr wrap="square" lIns="0" rIns="0">
-            <a:spAutoFit/>
-          </a:bodyPr>
-          <a:lstStyle/>
-          <a:p>
-            <a:pPr algn="l">
-              <a:defRPr sz="1200" b="0">
-                <a:solidFill>
-                  <a:srgbClr val="7B7B96"/>
-                </a:solidFill>
-                <a:latin typeface="Calibri"/>
-              </a:defRPr>
-            </a:pPr>
-            <a:r>
-              <a:t>75 – 95 min</a:t>
+            <a:off x="731520" y="914400"/>
+            <a:ext cx="10515600" cy="1097280"/>
+          </a:xfrm>
+          <a:prstGeom prst="rect">
+            <a:avLst/>
+          </a:prstGeom>
+          <a:noFill/>
+        </p:spPr>
+        <p:txBody>
+          <a:bodyPr wrap="square" lIns="0" rIns="0">
+            <a:spAutoFit/>
+          </a:bodyPr>
+          <a:lstStyle/>
+          <a:p>
+            <a:pPr algn="l">
+              <a:defRPr sz="3400" b="1">
+                <a:solidFill>
+                  <a:srgbClr val="FFFFFF"/>
+                </a:solidFill>
+                <a:latin typeface="Calibri"/>
+              </a:defRPr>
+            </a:pPr>
+            <a:r>
+              <a:t>Sort Your Own Practice</a:t>
             </a:r>
           </a:p>
         </p:txBody>
@@ -5998,22 +5850,22 @@
         </p:nvSpPr>
         <p:spPr>
           <a:xfrm>
-            <a:off x="731520" y="1828800"/>
-            <a:ext cx="10515600" cy="1371600"/>
-          </a:xfrm>
-          <a:prstGeom prst="rect">
-            <a:avLst/>
-          </a:prstGeom>
-          <a:noFill/>
-        </p:spPr>
-        <p:txBody>
-          <a:bodyPr wrap="square" lIns="0" rIns="0">
-            <a:spAutoFit/>
-          </a:bodyPr>
-          <a:lstStyle/>
-          <a:p>
-            <a:pPr algn="l">
-              <a:defRPr sz="3800" b="1">
+            <a:off x="731520" y="2103120"/>
+            <a:ext cx="10515600" cy="2743200"/>
+          </a:xfrm>
+          <a:prstGeom prst="rect">
+            <a:avLst/>
+          </a:prstGeom>
+          <a:noFill/>
+        </p:spPr>
+        <p:txBody>
+          <a:bodyPr wrap="square" lIns="0" rIns="0">
+            <a:spAutoFit/>
+          </a:bodyPr>
+          <a:lstStyle/>
+          <a:p>
+            <a:pPr algn="l">
+              <a:defRPr sz="1900" b="0">
                 <a:solidFill>
                   <a:srgbClr val="FFFFFF"/>
                 </a:solidFill>
@@ -6021,82 +5873,35 @@
               </a:defRPr>
             </a:pPr>
             <a:r>
-              <a:t>Digital vs Digitised Youth Work</a:t>
-            </a:r>
-          </a:p>
-        </p:txBody>
-      </p:sp>
-      <p:sp>
-        <p:nvSpPr>
-          <p:cNvPr id="6" name="TextBox 5"/>
-          <p:cNvSpPr txBox="1"/>
-          <p:nvPr/>
-        </p:nvSpPr>
-        <p:spPr>
-          <a:xfrm>
-            <a:off x="731520" y="3200400"/>
-            <a:ext cx="10515600" cy="3200400"/>
-          </a:xfrm>
-          <a:prstGeom prst="rect">
-            <a:avLst/>
-          </a:prstGeom>
-          <a:noFill/>
-        </p:spPr>
-        <p:txBody>
-          <a:bodyPr wrap="square" lIns="0">
-            <a:spAutoFit/>
-          </a:bodyPr>
-          <a:lstStyle/>
-          <a:p>
-            <a:pPr>
-              <a:spcAft>
-                <a:spcPts val="800"/>
-              </a:spcAft>
-              <a:defRPr sz="1700">
-                <a:solidFill>
-                  <a:srgbClr val="FFFFFF"/>
-                </a:solidFill>
-                <a:latin typeface="Calibri"/>
-              </a:defRPr>
-            </a:pPr>
-            <a:r>
-              <a:t>•  Digitised = taking what you already do and putting it on a screen (paper form → Google Form)</a:t>
-            </a:r>
-          </a:p>
-          <a:p>
-            <a:pPr>
-              <a:spcAft>
-                <a:spcPts val="800"/>
-              </a:spcAft>
-              <a:defRPr sz="1700">
-                <a:solidFill>
-                  <a:srgbClr val="FFFFFF"/>
-                </a:solidFill>
-                <a:latin typeface="Calibri"/>
-              </a:defRPr>
-            </a:pPr>
-            <a:r>
-              <a:t>•  Digital = designing an experience that only works because it's online (anonymous polling, real-time collaboration, adaptive difficulty)</a:t>
-            </a:r>
-          </a:p>
-          <a:p>
-            <a:pPr>
-              <a:spcAft>
-                <a:spcPts val="800"/>
-              </a:spcAft>
-              <a:defRPr sz="1700">
-                <a:solidFill>
-                  <a:srgbClr val="FFFFFF"/>
-                </a:solidFill>
-                <a:latin typeface="Calibri"/>
-              </a:defRPr>
-            </a:pPr>
-            <a:r>
-              <a:t>•  The environment IS the practice — every setting (timer, names, chat, scores) is a youth work decision you're making for the young person</a:t>
-            </a:r>
-          </a:p>
-        </p:txBody>
-      </p:sp>
+              <a:t>Two columns on the whiteboard: DIGITISED and DIGITAL. On a sticky note, write one activity you currently run and stick it under the column it fits. Be honest — digitised paper is fine, just name it. Walk the wall.</a:t>
+            </a:r>
+          </a:p>
+        </p:txBody>
+      </p:sp>
+      <p:pic>
+        <p:nvPicPr>
+          <p:cNvPr id="6" name="Picture 5" descr="logo.png"/>
+          <p:cNvPicPr>
+            <a:picLocks noChangeAspect="1"/>
+          </p:cNvPicPr>
+          <p:nvPr/>
+        </p:nvPicPr>
+        <p:blipFill>
+          <a:blip r:embed="rId2"/>
+          <a:stretch>
+            <a:fillRect/>
+          </a:stretch>
+        </p:blipFill>
+        <p:spPr>
+          <a:xfrm>
+            <a:off x="10515600" y="6355080"/>
+            <a:ext cx="1180586" cy="274320"/>
+          </a:xfrm>
+          <a:prstGeom prst="rect">
+            <a:avLst/>
+          </a:prstGeom>
+        </p:spPr>
+      </p:pic>
       <p:sp>
         <p:nvSpPr>
           <p:cNvPr id="7" name="TextBox 6"/>
@@ -6128,7 +5933,7 @@
               </a:defRPr>
             </a:pPr>
             <a:r>
-              <a:t>Robocode × LIA  ·  Digital Youth Work CPD  ·  Session 1 of 6</a:t>
+              <a:t>Session 1  ·  KEY IDEAS</a:t>
             </a:r>
           </a:p>
         </p:txBody>
@@ -6269,7 +6074,7 @@
               </a:defRPr>
             </a:pPr>
             <a:r>
-              <a:t>Sort the Examples</a:t>
+              <a:t>Values Hidden in Settings</a:t>
             </a:r>
           </a:p>
         </p:txBody>
@@ -6283,21 +6088,21 @@
         <p:spPr>
           <a:xfrm>
             <a:off x="731520" y="2103120"/>
-            <a:ext cx="10515600" cy="1828800"/>
-          </a:xfrm>
-          <a:prstGeom prst="rect">
-            <a:avLst/>
-          </a:prstGeom>
-          <a:noFill/>
-        </p:spPr>
-        <p:txBody>
-          <a:bodyPr wrap="square" lIns="0" rIns="0">
-            <a:spAutoFit/>
-          </a:bodyPr>
-          <a:lstStyle/>
-          <a:p>
-            <a:pPr algn="l">
-              <a:defRPr sz="1700" b="0">
+            <a:ext cx="10515600" cy="2743200"/>
+          </a:xfrm>
+          <a:prstGeom prst="rect">
+            <a:avLst/>
+          </a:prstGeom>
+          <a:noFill/>
+        </p:spPr>
+        <p:txBody>
+          <a:bodyPr wrap="square" lIns="0" rIns="0">
+            <a:spAutoFit/>
+          </a:bodyPr>
+          <a:lstStyle/>
+          <a:p>
+            <a:pPr algn="l">
+              <a:defRPr sz="1900" b="0">
                 <a:solidFill>
                   <a:srgbClr val="FFFFFF"/>
                 </a:solidFill>
@@ -6305,153 +6110,14 @@
               </a:defRPr>
             </a:pPr>
             <a:r>
-              <a:t>Facilitator reads out 8 examples. Participants hold up a card: 'DIGITISED' or 'DIGITAL'. Discuss any disagreements.</a:t>
-            </a:r>
-          </a:p>
-        </p:txBody>
-      </p:sp>
-      <p:sp>
-        <p:nvSpPr>
-          <p:cNvPr id="6" name="TextBox 5"/>
-          <p:cNvSpPr txBox="1"/>
-          <p:nvPr/>
-        </p:nvSpPr>
-        <p:spPr>
-          <a:xfrm>
-            <a:off x="731520" y="3566160"/>
-            <a:ext cx="10515600" cy="365760"/>
-          </a:xfrm>
-          <a:prstGeom prst="rect">
-            <a:avLst/>
-          </a:prstGeom>
-          <a:noFill/>
-        </p:spPr>
-        <p:txBody>
-          <a:bodyPr wrap="square" lIns="0" rIns="0">
-            <a:spAutoFit/>
-          </a:bodyPr>
-          <a:lstStyle/>
-          <a:p>
-            <a:pPr algn="l">
-              <a:defRPr sz="1300" b="1">
-                <a:solidFill>
-                  <a:srgbClr val="7B61FF"/>
-                </a:solidFill>
-                <a:latin typeface="Calibri"/>
-              </a:defRPr>
-            </a:pPr>
-            <a:r>
-              <a:t>Examples:</a:t>
-            </a:r>
-          </a:p>
-        </p:txBody>
-      </p:sp>
-      <p:sp>
-        <p:nvSpPr>
-          <p:cNvPr id="7" name="TextBox 6"/>
-          <p:cNvSpPr txBox="1"/>
-          <p:nvPr/>
-        </p:nvSpPr>
-        <p:spPr>
-          <a:xfrm>
-            <a:off x="731520" y="3931920"/>
-            <a:ext cx="10515600" cy="2743200"/>
-          </a:xfrm>
-          <a:prstGeom prst="rect">
-            <a:avLst/>
-          </a:prstGeom>
-          <a:noFill/>
-        </p:spPr>
-        <p:txBody>
-          <a:bodyPr wrap="square" lIns="0">
-            <a:spAutoFit/>
-          </a:bodyPr>
-          <a:lstStyle/>
-          <a:p>
-            <a:pPr>
-              <a:spcAft>
-                <a:spcPts val="800"/>
-              </a:spcAft>
-              <a:defRPr sz="1300">
-                <a:solidFill>
-                  <a:srgbClr val="B8B8D0"/>
-                </a:solidFill>
-                <a:latin typeface="Calibri"/>
-              </a:defRPr>
-            </a:pPr>
-            <a:r>
-              <a:t>•  A paper register replaced by a Google Form → DIGITISED</a:t>
-            </a:r>
-          </a:p>
-          <a:p>
-            <a:pPr>
-              <a:spcAft>
-                <a:spcPts val="800"/>
-              </a:spcAft>
-              <a:defRPr sz="1300">
-                <a:solidFill>
-                  <a:srgbClr val="B8B8D0"/>
-                </a:solidFill>
-                <a:latin typeface="Calibri"/>
-              </a:defRPr>
-            </a:pPr>
-            <a:r>
-              <a:t>•  A Kahoot quiz with anonymous mode so shy young people contribute → DIGITAL</a:t>
-            </a:r>
-          </a:p>
-          <a:p>
-            <a:pPr>
-              <a:spcAft>
-                <a:spcPts val="800"/>
-              </a:spcAft>
-              <a:defRPr sz="1300">
-                <a:solidFill>
-                  <a:srgbClr val="B8B8D0"/>
-                </a:solidFill>
-                <a:latin typeface="Calibri"/>
-              </a:defRPr>
-            </a:pPr>
-            <a:r>
-              <a:t>•  Emailing a worksheet instead of printing it → DIGITISED</a:t>
-            </a:r>
-          </a:p>
-          <a:p>
-            <a:pPr>
-              <a:spcAft>
-                <a:spcPts val="800"/>
-              </a:spcAft>
-              <a:defRPr sz="1300">
-                <a:solidFill>
-                  <a:srgbClr val="B8B8D0"/>
-                </a:solidFill>
-                <a:latin typeface="Calibri"/>
-              </a:defRPr>
-            </a:pPr>
-            <a:r>
-              <a:t>•  A Discord server where young people moderate their own channels → DIGITAL</a:t>
-            </a:r>
-          </a:p>
-          <a:p>
-            <a:pPr>
-              <a:spcAft>
-                <a:spcPts val="800"/>
-              </a:spcAft>
-              <a:defRPr sz="1300">
-                <a:solidFill>
-                  <a:srgbClr val="B8B8D0"/>
-                </a:solidFill>
-                <a:latin typeface="Calibri"/>
-              </a:defRPr>
-            </a:pPr>
-            <a:r>
-              <a:t>•  Filming a session and putting it on YouTube → DIGITISED</a:t>
+              <a:t>One setting projected on screen (leaderboard, timer, chat off, anonymous). In pairs, write on a sticky note the value that setting expresses. Compare. Same setting, different values? That's the conversation.</a:t>
             </a:r>
           </a:p>
         </p:txBody>
       </p:sp>
       <p:pic>
         <p:nvPicPr>
-          <p:cNvPr id="8" name="Picture 7" descr="logo.png"/>
+          <p:cNvPr id="6" name="Picture 5" descr="logo.png"/>
           <p:cNvPicPr>
             <a:picLocks noChangeAspect="1"/>
           </p:cNvPicPr>
@@ -6475,7 +6141,7 @@
       </p:pic>
       <p:sp>
         <p:nvSpPr>
-          <p:cNvPr id="9" name="TextBox 8"/>
+          <p:cNvPr id="7" name="TextBox 6"/>
           <p:cNvSpPr txBox="1"/>
           <p:nvPr/>
         </p:nvSpPr>
@@ -7103,7 +6769,7 @@
               </a:defRPr>
             </a:pPr>
             <a:r>
-              <a:t>Sort Your Own Practice</a:t>
+              <a:t>One Slide, One Question</a:t>
             </a:r>
           </a:p>
         </p:txBody>
@@ -7117,21 +6783,21 @@
         <p:spPr>
           <a:xfrm>
             <a:off x="731520" y="2103120"/>
-            <a:ext cx="10515600" cy="1828800"/>
-          </a:xfrm>
-          <a:prstGeom prst="rect">
-            <a:avLst/>
-          </a:prstGeom>
-          <a:noFill/>
-        </p:spPr>
-        <p:txBody>
-          <a:bodyPr wrap="square" lIns="0" rIns="0">
-            <a:spAutoFit/>
-          </a:bodyPr>
-          <a:lstStyle/>
-          <a:p>
-            <a:pPr algn="l">
-              <a:defRPr sz="1700" b="0">
+            <a:ext cx="10515600" cy="2743200"/>
+          </a:xfrm>
+          <a:prstGeom prst="rect">
+            <a:avLst/>
+          </a:prstGeom>
+          <a:noFill/>
+        </p:spPr>
+        <p:txBody>
+          <a:bodyPr wrap="square" lIns="0" rIns="0">
+            <a:spAutoFit/>
+          </a:bodyPr>
+          <a:lstStyle/>
+          <a:p>
+            <a:pPr algn="l">
+              <a:defRPr sz="1900" b="0">
                 <a:solidFill>
                   <a:srgbClr val="FFFFFF"/>
                 </a:solidFill>
@@ -7139,7 +6805,7 @@
               </a:defRPr>
             </a:pPr>
             <a:r>
-              <a:t>Two boards on the wall: DIGITISED and DIGITAL. Everyone takes one activity they currently run and sticks it on whichever board it fits. Be honest — if it's digitised paper, that's fine, just name it. Walk the wall.</a:t>
+              <a:t>A screenshot of a Kahoot setup screen is projected. In pairs, write one question you'd ask the person who set it up. Read a few aloud — you've just written your own facilitator audit.</a:t>
             </a:r>
           </a:p>
         </p:txBody>
@@ -7218,7 +6884,7 @@
     <p:bg>
       <p:bgPr>
         <a:solidFill>
-          <a:srgbClr val="161627"/>
+          <a:srgbClr val="0D0D1A"/>
         </a:solidFill>
         <a:effectLst/>
       </p:bgPr>
@@ -7239,13 +6905,13 @@
         <p:spPr>
           <a:xfrm>
             <a:off x="0" y="0"/>
-            <a:ext cx="12191695" cy="109728"/>
+            <a:ext cx="228600" cy="6858000"/>
           </a:xfrm>
           <a:prstGeom prst="rect">
             <a:avLst/>
           </a:prstGeom>
           <a:solidFill>
-            <a:srgbClr val="7B61FF"/>
+            <a:srgbClr val="FFB800"/>
           </a:solidFill>
           <a:ln>
             <a:noFill/>
@@ -7281,7 +6947,7 @@
         </p:nvSpPr>
         <p:spPr>
           <a:xfrm>
-            <a:off x="731520" y="365760"/>
+            <a:off x="731520" y="411480"/>
             <a:ext cx="5486400" cy="365760"/>
           </a:xfrm>
           <a:prstGeom prst="rect">
@@ -7296,15 +6962,15 @@
           <a:lstStyle/>
           <a:p>
             <a:pPr algn="l">
-              <a:defRPr sz="1200" b="1">
-                <a:solidFill>
-                  <a:srgbClr val="7B61FF"/>
-                </a:solidFill>
-                <a:latin typeface="Calibri"/>
-              </a:defRPr>
-            </a:pPr>
-            <a:r>
-              <a:t>KEY IDEAS</a:t>
+              <a:defRPr sz="1400" b="1">
+                <a:solidFill>
+                  <a:srgbClr val="FFB800"/>
+                </a:solidFill>
+                <a:latin typeface="Calibri"/>
+              </a:defRPr>
+            </a:pPr>
+            <a:r>
+              <a:t>DISCUSSION</a:t>
             </a:r>
           </a:p>
         </p:txBody>
@@ -7317,22 +6983,58 @@
         </p:nvSpPr>
         <p:spPr>
           <a:xfrm>
-            <a:off x="731520" y="914400"/>
-            <a:ext cx="10515600" cy="1097280"/>
-          </a:xfrm>
-          <a:prstGeom prst="rect">
-            <a:avLst/>
-          </a:prstGeom>
-          <a:noFill/>
-        </p:spPr>
-        <p:txBody>
-          <a:bodyPr wrap="square" lIns="0" rIns="0">
-            <a:spAutoFit/>
-          </a:bodyPr>
-          <a:lstStyle/>
-          <a:p>
-            <a:pPr algn="l">
-              <a:defRPr sz="3400" b="1">
+            <a:off x="731520" y="868680"/>
+            <a:ext cx="5486400" cy="365760"/>
+          </a:xfrm>
+          <a:prstGeom prst="rect">
+            <a:avLst/>
+          </a:prstGeom>
+          <a:noFill/>
+        </p:spPr>
+        <p:txBody>
+          <a:bodyPr wrap="square" lIns="0" rIns="0">
+            <a:spAutoFit/>
+          </a:bodyPr>
+          <a:lstStyle/>
+          <a:p>
+            <a:pPr algn="l">
+              <a:defRPr sz="1200" b="0">
+                <a:solidFill>
+                  <a:srgbClr val="7B7B96"/>
+                </a:solidFill>
+                <a:latin typeface="Calibri"/>
+              </a:defRPr>
+            </a:pPr>
+            <a:r>
+              <a:t>95 – 150 min</a:t>
+            </a:r>
+          </a:p>
+        </p:txBody>
+      </p:sp>
+      <p:sp>
+        <p:nvSpPr>
+          <p:cNvPr id="5" name="TextBox 4"/>
+          <p:cNvSpPr txBox="1"/>
+          <p:nvPr/>
+        </p:nvSpPr>
+        <p:spPr>
+          <a:xfrm>
+            <a:off x="731520" y="1828800"/>
+            <a:ext cx="10515600" cy="1371600"/>
+          </a:xfrm>
+          <a:prstGeom prst="rect">
+            <a:avLst/>
+          </a:prstGeom>
+          <a:noFill/>
+        </p:spPr>
+        <p:txBody>
+          <a:bodyPr wrap="square" lIns="0" rIns="0">
+            <a:spAutoFit/>
+          </a:bodyPr>
+          <a:lstStyle/>
+          <a:p>
+            <a:pPr algn="l">
+              <a:defRPr sz="3800" b="1">
                 <a:solidFill>
                   <a:srgbClr val="FFFFFF"/>
                 </a:solidFill>
@@ -7340,35 +7042,74 @@
               </a:defRPr>
             </a:pPr>
             <a:r>
-              <a:t>Values Hidden in Settings</a:t>
-            </a:r>
-          </a:p>
-        </p:txBody>
-      </p:sp>
-      <p:sp>
-        <p:nvSpPr>
-          <p:cNvPr id="5" name="TextBox 4"/>
-          <p:cNvSpPr txBox="1"/>
-          <p:nvPr/>
-        </p:nvSpPr>
-        <p:spPr>
-          <a:xfrm>
-            <a:off x="731520" y="2103120"/>
-            <a:ext cx="10515600" cy="1828800"/>
-          </a:xfrm>
-          <a:prstGeom prst="rect">
-            <a:avLst/>
-          </a:prstGeom>
-          <a:noFill/>
-        </p:spPr>
-        <p:txBody>
-          <a:bodyPr wrap="square" lIns="0" rIns="0">
-            <a:spAutoFit/>
-          </a:bodyPr>
-          <a:lstStyle/>
-          <a:p>
-            <a:pPr algn="l">
-              <a:defRPr sz="1700" b="0">
+              <a:t>Discussion</a:t>
+            </a:r>
+          </a:p>
+        </p:txBody>
+      </p:sp>
+      <p:sp>
+        <p:nvSpPr>
+          <p:cNvPr id="6" name="TextBox 5"/>
+          <p:cNvSpPr txBox="1"/>
+          <p:nvPr/>
+        </p:nvSpPr>
+        <p:spPr>
+          <a:xfrm>
+            <a:off x="731520" y="2926080"/>
+            <a:ext cx="10515600" cy="457200"/>
+          </a:xfrm>
+          <a:prstGeom prst="rect">
+            <a:avLst/>
+          </a:prstGeom>
+          <a:noFill/>
+        </p:spPr>
+        <p:txBody>
+          <a:bodyPr wrap="square" lIns="0" rIns="0">
+            <a:spAutoFit/>
+          </a:bodyPr>
+          <a:lstStyle/>
+          <a:p>
+            <a:pPr algn="l">
+              <a:defRPr sz="1400" b="0">
+                <a:solidFill>
+                  <a:srgbClr val="B8B8D0"/>
+                </a:solidFill>
+                <a:latin typeface="Calibri"/>
+              </a:defRPr>
+            </a:pPr>
+            <a:r>
+              <a:t>6 activities in this block:</a:t>
+            </a:r>
+          </a:p>
+        </p:txBody>
+      </p:sp>
+      <p:sp>
+        <p:nvSpPr>
+          <p:cNvPr id="7" name="TextBox 6"/>
+          <p:cNvSpPr txBox="1"/>
+          <p:nvPr/>
+        </p:nvSpPr>
+        <p:spPr>
+          <a:xfrm>
+            <a:off x="731520" y="3383280"/>
+            <a:ext cx="10515600" cy="3017520"/>
+          </a:xfrm>
+          <a:prstGeom prst="rect">
+            <a:avLst/>
+          </a:prstGeom>
+          <a:noFill/>
+        </p:spPr>
+        <p:txBody>
+          <a:bodyPr wrap="square" lIns="0">
+            <a:spAutoFit/>
+          </a:bodyPr>
+          <a:lstStyle/>
+          <a:p>
+            <a:pPr>
+              <a:spcAft>
+                <a:spcPts val="800"/>
+              </a:spcAft>
+              <a:defRPr sz="1600">
                 <a:solidFill>
                   <a:srgbClr val="FFFFFF"/>
                 </a:solidFill>
@@ -7376,38 +7117,94 @@
               </a:defRPr>
             </a:pPr>
             <a:r>
-              <a:t>Facilitator shows a setting (leaderboard, timer, chat disabled, anonymous mode). In pairs, write down what value that setting expresses. Compare answers across the room. Same setting, different values? That's the conversation.</a:t>
-            </a:r>
-          </a:p>
-        </p:txBody>
-      </p:sp>
-      <p:pic>
-        <p:nvPicPr>
-          <p:cNvPr id="6" name="Picture 5" descr="logo.png"/>
-          <p:cNvPicPr>
-            <a:picLocks noChangeAspect="1"/>
-          </p:cNvPicPr>
-          <p:nvPr/>
-        </p:nvPicPr>
-        <p:blipFill>
-          <a:blip r:embed="rId2"/>
-          <a:stretch>
-            <a:fillRect/>
-          </a:stretch>
-        </p:blipFill>
-        <p:spPr>
-          <a:xfrm>
-            <a:off x="10515600" y="6355080"/>
-            <a:ext cx="1180586" cy="274320"/>
-          </a:xfrm>
-          <a:prstGeom prst="rect">
-            <a:avLst/>
-          </a:prstGeom>
-        </p:spPr>
-      </p:pic>
-      <p:sp>
-        <p:nvSpPr>
-          <p:cNvPr id="7" name="TextBox 6"/>
+              <a:t>→  Tool Speed-Date</a:t>
+            </a:r>
+          </a:p>
+          <a:p>
+            <a:pPr>
+              <a:spcAft>
+                <a:spcPts val="800"/>
+              </a:spcAft>
+              <a:defRPr sz="1600">
+                <a:solidFill>
+                  <a:srgbClr val="FFFFFF"/>
+                </a:solidFill>
+                <a:latin typeface="Calibri"/>
+              </a:defRPr>
+            </a:pPr>
+            <a:r>
+              <a:t>→  Design Your Own</a:t>
+            </a:r>
+          </a:p>
+          <a:p>
+            <a:pPr>
+              <a:spcAft>
+                <a:spcPts val="800"/>
+              </a:spcAft>
+              <a:defRPr sz="1600">
+                <a:solidFill>
+                  <a:srgbClr val="FFFFFF"/>
+                </a:solidFill>
+                <a:latin typeface="Calibri"/>
+              </a:defRPr>
+            </a:pPr>
+            <a:r>
+              <a:t>→  Pitch Your Activity</a:t>
+            </a:r>
+          </a:p>
+          <a:p>
+            <a:pPr>
+              <a:spcAft>
+                <a:spcPts val="800"/>
+              </a:spcAft>
+              <a:defRPr sz="1600">
+                <a:solidFill>
+                  <a:srgbClr val="FFFFFF"/>
+                </a:solidFill>
+                <a:latin typeface="Calibri"/>
+              </a:defRPr>
+            </a:pPr>
+            <a:r>
+              <a:t>→  Objection Panel</a:t>
+            </a:r>
+          </a:p>
+          <a:p>
+            <a:pPr>
+              <a:spcAft>
+                <a:spcPts val="800"/>
+              </a:spcAft>
+              <a:defRPr sz="1600">
+                <a:solidFill>
+                  <a:srgbClr val="FFFFFF"/>
+                </a:solidFill>
+                <a:latin typeface="Calibri"/>
+              </a:defRPr>
+            </a:pPr>
+            <a:r>
+              <a:t>→  Mix and Match</a:t>
+            </a:r>
+          </a:p>
+          <a:p>
+            <a:pPr>
+              <a:spcAft>
+                <a:spcPts val="800"/>
+              </a:spcAft>
+              <a:defRPr sz="1600">
+                <a:solidFill>
+                  <a:srgbClr val="FFFFFF"/>
+                </a:solidFill>
+                <a:latin typeface="Calibri"/>
+              </a:defRPr>
+            </a:pPr>
+            <a:r>
+              <a:t>→  Gallery Walk</a:t>
+            </a:r>
+          </a:p>
+        </p:txBody>
+      </p:sp>
+      <p:sp>
+        <p:nvSpPr>
+          <p:cNvPr id="8" name="TextBox 7"/>
           <p:cNvSpPr txBox="1"/>
           <p:nvPr/>
         </p:nvSpPr>
@@ -7436,7 +7233,7 @@
               </a:defRPr>
             </a:pPr>
             <a:r>
-              <a:t>Session 1  ·  KEY IDEAS</a:t>
+              <a:t>Robocode × LIA  ·  Digital Youth Work CPD  ·  Session 1 of 6</a:t>
             </a:r>
           </a:p>
         </p:txBody>
@@ -7482,7 +7279,7 @@
             <a:avLst/>
           </a:prstGeom>
           <a:solidFill>
-            <a:srgbClr val="7B61FF"/>
+            <a:srgbClr val="FFB800"/>
           </a:solidFill>
           <a:ln>
             <a:noFill/>
@@ -7535,13 +7332,13 @@
             <a:pPr algn="l">
               <a:defRPr sz="1200" b="1">
                 <a:solidFill>
-                  <a:srgbClr val="7B61FF"/>
-                </a:solidFill>
-                <a:latin typeface="Calibri"/>
-              </a:defRPr>
-            </a:pPr>
-            <a:r>
-              <a:t>KEY IDEAS</a:t>
+                  <a:srgbClr val="FFB800"/>
+                </a:solidFill>
+                <a:latin typeface="Calibri"/>
+              </a:defRPr>
+            </a:pPr>
+            <a:r>
+              <a:t>DISCUSSION</a:t>
             </a:r>
           </a:p>
         </p:txBody>
@@ -7577,7 +7374,7 @@
               </a:defRPr>
             </a:pPr>
             <a:r>
-              <a:t>One Slide, One Question</a:t>
+              <a:t>Tool Speed-Date</a:t>
             </a:r>
           </a:p>
         </p:txBody>
@@ -7591,21 +7388,57 @@
         <p:spPr>
           <a:xfrm>
             <a:off x="731520" y="2103120"/>
-            <a:ext cx="10515600" cy="1828800"/>
-          </a:xfrm>
-          <a:prstGeom prst="rect">
-            <a:avLst/>
-          </a:prstGeom>
-          <a:noFill/>
-        </p:spPr>
-        <p:txBody>
-          <a:bodyPr wrap="square" lIns="0" rIns="0">
-            <a:spAutoFit/>
-          </a:bodyPr>
-          <a:lstStyle/>
-          <a:p>
-            <a:pPr algn="l">
-              <a:defRPr sz="1700" b="0">
+            <a:ext cx="10515600" cy="365760"/>
+          </a:xfrm>
+          <a:prstGeom prst="rect">
+            <a:avLst/>
+          </a:prstGeom>
+          <a:noFill/>
+        </p:spPr>
+        <p:txBody>
+          <a:bodyPr wrap="square" lIns="0" rIns="0">
+            <a:spAutoFit/>
+          </a:bodyPr>
+          <a:lstStyle/>
+          <a:p>
+            <a:pPr algn="l">
+              <a:defRPr sz="1400" b="1">
+                <a:solidFill>
+                  <a:srgbClr val="E91E8C"/>
+                </a:solidFill>
+                <a:latin typeface="Calibri"/>
+              </a:defRPr>
+            </a:pPr>
+            <a:r>
+              <a:t>🛠  Mentimeter + Padlet + Kahoot</a:t>
+            </a:r>
+          </a:p>
+        </p:txBody>
+      </p:sp>
+      <p:sp>
+        <p:nvSpPr>
+          <p:cNvPr id="6" name="TextBox 5"/>
+          <p:cNvSpPr txBox="1"/>
+          <p:nvPr/>
+        </p:nvSpPr>
+        <p:spPr>
+          <a:xfrm>
+            <a:off x="731520" y="2560320"/>
+            <a:ext cx="10515600" cy="2743200"/>
+          </a:xfrm>
+          <a:prstGeom prst="rect">
+            <a:avLst/>
+          </a:prstGeom>
+          <a:noFill/>
+        </p:spPr>
+        <p:txBody>
+          <a:bodyPr wrap="square" lIns="0" rIns="0">
+            <a:spAutoFit/>
+          </a:bodyPr>
+          <a:lstStyle/>
+          <a:p>
+            <a:pPr algn="l">
+              <a:defRPr sz="1900" b="0">
                 <a:solidFill>
                   <a:srgbClr val="FFFFFF"/>
                 </a:solidFill>
@@ -7613,14 +7446,14 @@
               </a:defRPr>
             </a:pPr>
             <a:r>
-              <a:t>Facilitator projects a screenshot of a Kahoot setup screen. Each pair writes one question they'd ask the person who set it up about why they made each choice. Read a few aloud — you've just written your own facilitator audit.</a:t>
+              <a:t>3-minute rotations. Each table has a different tool open. Try it for 3 minutes, then rotate. At the end, vote: which felt most useful for YOUR group?</a:t>
             </a:r>
           </a:p>
         </p:txBody>
       </p:sp>
       <p:pic>
         <p:nvPicPr>
-          <p:cNvPr id="6" name="Picture 5" descr="logo.png"/>
+          <p:cNvPr id="7" name="Picture 6" descr="logo.png"/>
           <p:cNvPicPr>
             <a:picLocks noChangeAspect="1"/>
           </p:cNvPicPr>
@@ -7644,7 +7477,7 @@
       </p:pic>
       <p:sp>
         <p:nvSpPr>
-          <p:cNvPr id="7" name="TextBox 6"/>
+          <p:cNvPr id="8" name="TextBox 7"/>
           <p:cNvSpPr txBox="1"/>
           <p:nvPr/>
         </p:nvSpPr>
@@ -7673,7 +7506,7 @@
               </a:defRPr>
             </a:pPr>
             <a:r>
-              <a:t>Session 1  ·  KEY IDEAS</a:t>
+              <a:t>Session 1  ·  DISCUSSION</a:t>
             </a:r>
           </a:p>
         </p:txBody>
@@ -7692,7 +7525,7 @@
     <p:bg>
       <p:bgPr>
         <a:solidFill>
-          <a:srgbClr val="0D0D1A"/>
+          <a:srgbClr val="161627"/>
         </a:solidFill>
         <a:effectLst/>
       </p:bgPr>
@@ -7713,7 +7546,7 @@
         <p:spPr>
           <a:xfrm>
             <a:off x="0" y="0"/>
-            <a:ext cx="228600" cy="6858000"/>
+            <a:ext cx="12191695" cy="109728"/>
           </a:xfrm>
           <a:prstGeom prst="rect">
             <a:avLst/>
@@ -7755,7 +7588,7 @@
         </p:nvSpPr>
         <p:spPr>
           <a:xfrm>
-            <a:off x="731520" y="411480"/>
+            <a:off x="731520" y="365760"/>
             <a:ext cx="5486400" cy="365760"/>
           </a:xfrm>
           <a:prstGeom prst="rect">
@@ -7770,79 +7603,115 @@
           <a:lstStyle/>
           <a:p>
             <a:pPr algn="l">
+              <a:defRPr sz="1200" b="1">
+                <a:solidFill>
+                  <a:srgbClr val="FFB800"/>
+                </a:solidFill>
+                <a:latin typeface="Calibri"/>
+              </a:defRPr>
+            </a:pPr>
+            <a:r>
+              <a:t>DISCUSSION</a:t>
+            </a:r>
+          </a:p>
+        </p:txBody>
+      </p:sp>
+      <p:sp>
+        <p:nvSpPr>
+          <p:cNvPr id="4" name="TextBox 3"/>
+          <p:cNvSpPr txBox="1"/>
+          <p:nvPr/>
+        </p:nvSpPr>
+        <p:spPr>
+          <a:xfrm>
+            <a:off x="731520" y="914400"/>
+            <a:ext cx="10515600" cy="1097280"/>
+          </a:xfrm>
+          <a:prstGeom prst="rect">
+            <a:avLst/>
+          </a:prstGeom>
+          <a:noFill/>
+        </p:spPr>
+        <p:txBody>
+          <a:bodyPr wrap="square" lIns="0" rIns="0">
+            <a:spAutoFit/>
+          </a:bodyPr>
+          <a:lstStyle/>
+          <a:p>
+            <a:pPr algn="l">
+              <a:defRPr sz="3400" b="1">
+                <a:solidFill>
+                  <a:srgbClr val="FFFFFF"/>
+                </a:solidFill>
+                <a:latin typeface="Calibri"/>
+              </a:defRPr>
+            </a:pPr>
+            <a:r>
+              <a:t>Design Your Own</a:t>
+            </a:r>
+          </a:p>
+        </p:txBody>
+      </p:sp>
+      <p:sp>
+        <p:nvSpPr>
+          <p:cNvPr id="5" name="TextBox 4"/>
+          <p:cNvSpPr txBox="1"/>
+          <p:nvPr/>
+        </p:nvSpPr>
+        <p:spPr>
+          <a:xfrm>
+            <a:off x="731520" y="2103120"/>
+            <a:ext cx="10515600" cy="365760"/>
+          </a:xfrm>
+          <a:prstGeom prst="rect">
+            <a:avLst/>
+          </a:prstGeom>
+          <a:noFill/>
+        </p:spPr>
+        <p:txBody>
+          <a:bodyPr wrap="square" lIns="0" rIns="0">
+            <a:spAutoFit/>
+          </a:bodyPr>
+          <a:lstStyle/>
+          <a:p>
+            <a:pPr algn="l">
               <a:defRPr sz="1400" b="1">
                 <a:solidFill>
-                  <a:srgbClr val="FFB800"/>
-                </a:solidFill>
-                <a:latin typeface="Calibri"/>
-              </a:defRPr>
-            </a:pPr>
-            <a:r>
-              <a:t>DISCUSSION</a:t>
-            </a:r>
-          </a:p>
-        </p:txBody>
-      </p:sp>
-      <p:sp>
-        <p:nvSpPr>
-          <p:cNvPr id="4" name="TextBox 3"/>
-          <p:cNvSpPr txBox="1"/>
-          <p:nvPr/>
-        </p:nvSpPr>
-        <p:spPr>
-          <a:xfrm>
-            <a:off x="731520" y="868680"/>
-            <a:ext cx="5486400" cy="365760"/>
-          </a:xfrm>
-          <a:prstGeom prst="rect">
-            <a:avLst/>
-          </a:prstGeom>
-          <a:noFill/>
-        </p:spPr>
-        <p:txBody>
-          <a:bodyPr wrap="square" lIns="0" rIns="0">
-            <a:spAutoFit/>
-          </a:bodyPr>
-          <a:lstStyle/>
-          <a:p>
-            <a:pPr algn="l">
-              <a:defRPr sz="1200" b="0">
-                <a:solidFill>
-                  <a:srgbClr val="7B7B96"/>
-                </a:solidFill>
-                <a:latin typeface="Calibri"/>
-              </a:defRPr>
-            </a:pPr>
-            <a:r>
-              <a:t>95 – 150 min</a:t>
-            </a:r>
-          </a:p>
-        </p:txBody>
-      </p:sp>
-      <p:sp>
-        <p:nvSpPr>
-          <p:cNvPr id="5" name="TextBox 4"/>
-          <p:cNvSpPr txBox="1"/>
-          <p:nvPr/>
-        </p:nvSpPr>
-        <p:spPr>
-          <a:xfrm>
-            <a:off x="731520" y="1828800"/>
-            <a:ext cx="10515600" cy="1371600"/>
-          </a:xfrm>
-          <a:prstGeom prst="rect">
-            <a:avLst/>
-          </a:prstGeom>
-          <a:noFill/>
-        </p:spPr>
-        <p:txBody>
-          <a:bodyPr wrap="square" lIns="0" rIns="0">
-            <a:spAutoFit/>
-          </a:bodyPr>
-          <a:lstStyle/>
-          <a:p>
-            <a:pPr algn="l">
-              <a:defRPr sz="3800" b="1">
+                  <a:srgbClr val="E91E8C"/>
+                </a:solidFill>
+                <a:latin typeface="Calibri"/>
+              </a:defRPr>
+            </a:pPr>
+            <a:r>
+              <a:t>🛠  Paper or Padlet</a:t>
+            </a:r>
+          </a:p>
+        </p:txBody>
+      </p:sp>
+      <p:sp>
+        <p:nvSpPr>
+          <p:cNvPr id="6" name="TextBox 5"/>
+          <p:cNvSpPr txBox="1"/>
+          <p:nvPr/>
+        </p:nvSpPr>
+        <p:spPr>
+          <a:xfrm>
+            <a:off x="731520" y="2560320"/>
+            <a:ext cx="10515600" cy="2743200"/>
+          </a:xfrm>
+          <a:prstGeom prst="rect">
+            <a:avLst/>
+          </a:prstGeom>
+          <a:noFill/>
+        </p:spPr>
+        <p:txBody>
+          <a:bodyPr wrap="square" lIns="0" rIns="0">
+            <a:spAutoFit/>
+          </a:bodyPr>
+          <a:lstStyle/>
+          <a:p>
+            <a:pPr algn="l">
+              <a:defRPr sz="1900" b="0">
                 <a:solidFill>
                   <a:srgbClr val="FFFFFF"/>
                 </a:solidFill>
@@ -7850,166 +7719,35 @@
               </a:defRPr>
             </a:pPr>
             <a:r>
-              <a:t>Discussion</a:t>
-            </a:r>
-          </a:p>
-        </p:txBody>
-      </p:sp>
-      <p:sp>
-        <p:nvSpPr>
-          <p:cNvPr id="6" name="TextBox 5"/>
-          <p:cNvSpPr txBox="1"/>
-          <p:nvPr/>
-        </p:nvSpPr>
-        <p:spPr>
-          <a:xfrm>
-            <a:off x="731520" y="2926080"/>
-            <a:ext cx="10515600" cy="457200"/>
-          </a:xfrm>
-          <a:prstGeom prst="rect">
-            <a:avLst/>
-          </a:prstGeom>
-          <a:noFill/>
-        </p:spPr>
-        <p:txBody>
-          <a:bodyPr wrap="square" lIns="0" rIns="0">
-            <a:spAutoFit/>
-          </a:bodyPr>
-          <a:lstStyle/>
-          <a:p>
-            <a:pPr algn="l">
-              <a:defRPr sz="1400" b="0">
-                <a:solidFill>
-                  <a:srgbClr val="B8B8D0"/>
-                </a:solidFill>
-                <a:latin typeface="Calibri"/>
-              </a:defRPr>
-            </a:pPr>
-            <a:r>
-              <a:t>6 activities in this block:</a:t>
-            </a:r>
-          </a:p>
-        </p:txBody>
-      </p:sp>
-      <p:sp>
-        <p:nvSpPr>
-          <p:cNvPr id="7" name="TextBox 6"/>
-          <p:cNvSpPr txBox="1"/>
-          <p:nvPr/>
-        </p:nvSpPr>
-        <p:spPr>
-          <a:xfrm>
-            <a:off x="731520" y="3383280"/>
-            <a:ext cx="10515600" cy="3017520"/>
-          </a:xfrm>
-          <a:prstGeom prst="rect">
-            <a:avLst/>
-          </a:prstGeom>
-          <a:noFill/>
-        </p:spPr>
-        <p:txBody>
-          <a:bodyPr wrap="square" lIns="0">
-            <a:spAutoFit/>
-          </a:bodyPr>
-          <a:lstStyle/>
-          <a:p>
-            <a:pPr>
-              <a:spcAft>
-                <a:spcPts val="800"/>
-              </a:spcAft>
-              <a:defRPr sz="1600">
-                <a:solidFill>
-                  <a:srgbClr val="FFFFFF"/>
-                </a:solidFill>
-                <a:latin typeface="Calibri"/>
-              </a:defRPr>
-            </a:pPr>
-            <a:r>
-              <a:t>→  Tool Speed-Date</a:t>
-            </a:r>
-          </a:p>
-          <a:p>
-            <a:pPr>
-              <a:spcAft>
-                <a:spcPts val="800"/>
-              </a:spcAft>
-              <a:defRPr sz="1600">
-                <a:solidFill>
-                  <a:srgbClr val="FFFFFF"/>
-                </a:solidFill>
-                <a:latin typeface="Calibri"/>
-              </a:defRPr>
-            </a:pPr>
-            <a:r>
-              <a:t>→  Design Your Own</a:t>
-            </a:r>
-          </a:p>
-          <a:p>
-            <a:pPr>
-              <a:spcAft>
-                <a:spcPts val="800"/>
-              </a:spcAft>
-              <a:defRPr sz="1600">
-                <a:solidFill>
-                  <a:srgbClr val="FFFFFF"/>
-                </a:solidFill>
-                <a:latin typeface="Calibri"/>
-              </a:defRPr>
-            </a:pPr>
-            <a:r>
-              <a:t>→  Pitch Your Activity</a:t>
-            </a:r>
-          </a:p>
-          <a:p>
-            <a:pPr>
-              <a:spcAft>
-                <a:spcPts val="800"/>
-              </a:spcAft>
-              <a:defRPr sz="1600">
-                <a:solidFill>
-                  <a:srgbClr val="FFFFFF"/>
-                </a:solidFill>
-                <a:latin typeface="Calibri"/>
-              </a:defRPr>
-            </a:pPr>
-            <a:r>
-              <a:t>→  Objection Panel</a:t>
-            </a:r>
-          </a:p>
-          <a:p>
-            <a:pPr>
-              <a:spcAft>
-                <a:spcPts val="800"/>
-              </a:spcAft>
-              <a:defRPr sz="1600">
-                <a:solidFill>
-                  <a:srgbClr val="FFFFFF"/>
-                </a:solidFill>
-                <a:latin typeface="Calibri"/>
-              </a:defRPr>
-            </a:pPr>
-            <a:r>
-              <a:t>→  Mix and Match</a:t>
-            </a:r>
-          </a:p>
-          <a:p>
-            <a:pPr>
-              <a:spcAft>
-                <a:spcPts val="800"/>
-              </a:spcAft>
-              <a:defRPr sz="1600">
-                <a:solidFill>
-                  <a:srgbClr val="FFFFFF"/>
-                </a:solidFill>
-                <a:latin typeface="Calibri"/>
-              </a:defRPr>
-            </a:pPr>
-            <a:r>
-              <a:t>→  Gallery Walk</a:t>
-            </a:r>
-          </a:p>
-        </p:txBody>
-      </p:sp>
+              <a:t>In pairs, sketch a 10-minute digital activity you could run with your group next week. Use any tool. Keep it simple. Write: What tool? What do participants do? What's the one setting you'd change to make it work for YOUR group?</a:t>
+            </a:r>
+          </a:p>
+        </p:txBody>
+      </p:sp>
+      <p:pic>
+        <p:nvPicPr>
+          <p:cNvPr id="7" name="Picture 6" descr="logo.png"/>
+          <p:cNvPicPr>
+            <a:picLocks noChangeAspect="1"/>
+          </p:cNvPicPr>
+          <p:nvPr/>
+        </p:nvPicPr>
+        <p:blipFill>
+          <a:blip r:embed="rId2"/>
+          <a:stretch>
+            <a:fillRect/>
+          </a:stretch>
+        </p:blipFill>
+        <p:spPr>
+          <a:xfrm>
+            <a:off x="10515600" y="6355080"/>
+            <a:ext cx="1180586" cy="274320"/>
+          </a:xfrm>
+          <a:prstGeom prst="rect">
+            <a:avLst/>
+          </a:prstGeom>
+        </p:spPr>
+      </p:pic>
       <p:sp>
         <p:nvSpPr>
           <p:cNvPr id="8" name="TextBox 7"/>
@@ -8041,7 +7779,7 @@
               </a:defRPr>
             </a:pPr>
             <a:r>
-              <a:t>Robocode × LIA  ·  Digital Youth Work CPD  ·  Session 1 of 6</a:t>
+              <a:t>Session 1  ·  DISCUSSION</a:t>
             </a:r>
           </a:p>
         </p:txBody>
@@ -8182,7 +7920,7 @@
               </a:defRPr>
             </a:pPr>
             <a:r>
-              <a:t>Tool Speed-Date</a:t>
+              <a:t>Pitch Your Activity</a:t>
             </a:r>
           </a:p>
         </p:txBody>
@@ -8196,57 +7934,21 @@
         <p:spPr>
           <a:xfrm>
             <a:off x="731520" y="2103120"/>
-            <a:ext cx="10515600" cy="365760"/>
-          </a:xfrm>
-          <a:prstGeom prst="rect">
-            <a:avLst/>
-          </a:prstGeom>
-          <a:noFill/>
-        </p:spPr>
-        <p:txBody>
-          <a:bodyPr wrap="square" lIns="0" rIns="0">
-            <a:spAutoFit/>
-          </a:bodyPr>
-          <a:lstStyle/>
-          <a:p>
-            <a:pPr algn="l">
-              <a:defRPr sz="1400" b="1">
-                <a:solidFill>
-                  <a:srgbClr val="E91E8C"/>
-                </a:solidFill>
-                <a:latin typeface="Calibri"/>
-              </a:defRPr>
-            </a:pPr>
-            <a:r>
-              <a:t>🛠  Mentimeter + Padlet + Kahoot</a:t>
-            </a:r>
-          </a:p>
-        </p:txBody>
-      </p:sp>
-      <p:sp>
-        <p:nvSpPr>
-          <p:cNvPr id="6" name="TextBox 5"/>
-          <p:cNvSpPr txBox="1"/>
-          <p:nvPr/>
-        </p:nvSpPr>
-        <p:spPr>
-          <a:xfrm>
-            <a:off x="731520" y="2560320"/>
-            <a:ext cx="10515600" cy="1828800"/>
-          </a:xfrm>
-          <a:prstGeom prst="rect">
-            <a:avLst/>
-          </a:prstGeom>
-          <a:noFill/>
-        </p:spPr>
-        <p:txBody>
-          <a:bodyPr wrap="square" lIns="0" rIns="0">
-            <a:spAutoFit/>
-          </a:bodyPr>
-          <a:lstStyle/>
-          <a:p>
-            <a:pPr algn="l">
-              <a:defRPr sz="1700" b="0">
+            <a:ext cx="10515600" cy="2743200"/>
+          </a:xfrm>
+          <a:prstGeom prst="rect">
+            <a:avLst/>
+          </a:prstGeom>
+          <a:noFill/>
+        </p:spPr>
+        <p:txBody>
+          <a:bodyPr wrap="square" lIns="0" rIns="0">
+            <a:spAutoFit/>
+          </a:bodyPr>
+          <a:lstStyle/>
+          <a:p>
+            <a:pPr algn="l">
+              <a:defRPr sz="1900" b="0">
                 <a:solidFill>
                   <a:srgbClr val="FFFFFF"/>
                 </a:solidFill>
@@ -8254,14 +7956,14 @@
               </a:defRPr>
             </a:pPr>
             <a:r>
-              <a:t>3-minute rotations. Each table has a different tool open. Try it for 3 minutes, then rotate. At the end, vote: which felt most useful for YOUR group?</a:t>
+              <a:t>Each pair gets 90 seconds to pitch their activity to another pair. No slides, no notes — just speak. The listening pair asks ONE question. Swap.</a:t>
             </a:r>
           </a:p>
         </p:txBody>
       </p:sp>
       <p:pic>
         <p:nvPicPr>
-          <p:cNvPr id="7" name="Picture 6" descr="logo.png"/>
+          <p:cNvPr id="6" name="Picture 5" descr="logo.png"/>
           <p:cNvPicPr>
             <a:picLocks noChangeAspect="1"/>
           </p:cNvPicPr>
@@ -8285,7 +7987,7 @@
       </p:pic>
       <p:sp>
         <p:nvSpPr>
-          <p:cNvPr id="8" name="TextBox 7"/>
+          <p:cNvPr id="7" name="TextBox 6"/>
           <p:cNvSpPr txBox="1"/>
           <p:nvPr/>
         </p:nvSpPr>
@@ -8455,7 +8157,7 @@
               </a:defRPr>
             </a:pPr>
             <a:r>
-              <a:t>Design Your Own</a:t>
+              <a:t>Objection Panel</a:t>
             </a:r>
           </a:p>
         </p:txBody>
@@ -8469,57 +8171,21 @@
         <p:spPr>
           <a:xfrm>
             <a:off x="731520" y="2103120"/>
-            <a:ext cx="10515600" cy="365760"/>
-          </a:xfrm>
-          <a:prstGeom prst="rect">
-            <a:avLst/>
-          </a:prstGeom>
-          <a:noFill/>
-        </p:spPr>
-        <p:txBody>
-          <a:bodyPr wrap="square" lIns="0" rIns="0">
-            <a:spAutoFit/>
-          </a:bodyPr>
-          <a:lstStyle/>
-          <a:p>
-            <a:pPr algn="l">
-              <a:defRPr sz="1400" b="1">
-                <a:solidFill>
-                  <a:srgbClr val="E91E8C"/>
-                </a:solidFill>
-                <a:latin typeface="Calibri"/>
-              </a:defRPr>
-            </a:pPr>
-            <a:r>
-              <a:t>🛠  Paper or Padlet</a:t>
-            </a:r>
-          </a:p>
-        </p:txBody>
-      </p:sp>
-      <p:sp>
-        <p:nvSpPr>
-          <p:cNvPr id="6" name="TextBox 5"/>
-          <p:cNvSpPr txBox="1"/>
-          <p:nvPr/>
-        </p:nvSpPr>
-        <p:spPr>
-          <a:xfrm>
-            <a:off x="731520" y="2560320"/>
-            <a:ext cx="10515600" cy="1828800"/>
-          </a:xfrm>
-          <a:prstGeom prst="rect">
-            <a:avLst/>
-          </a:prstGeom>
-          <a:noFill/>
-        </p:spPr>
-        <p:txBody>
-          <a:bodyPr wrap="square" lIns="0" rIns="0">
-            <a:spAutoFit/>
-          </a:bodyPr>
-          <a:lstStyle/>
-          <a:p>
-            <a:pPr algn="l">
-              <a:defRPr sz="1700" b="0">
+            <a:ext cx="10515600" cy="2743200"/>
+          </a:xfrm>
+          <a:prstGeom prst="rect">
+            <a:avLst/>
+          </a:prstGeom>
+          <a:noFill/>
+        </p:spPr>
+        <p:txBody>
+          <a:bodyPr wrap="square" lIns="0" rIns="0">
+            <a:spAutoFit/>
+          </a:bodyPr>
+          <a:lstStyle/>
+          <a:p>
+            <a:pPr algn="l">
+              <a:defRPr sz="1900" b="0">
                 <a:solidFill>
                   <a:srgbClr val="FFFFFF"/>
                 </a:solidFill>
@@ -8527,14 +8193,14 @@
               </a:defRPr>
             </a:pPr>
             <a:r>
-              <a:t>In pairs, sketch a 10-minute digital activity you could run with your group next week. Use any tool. Keep it simple. Write: What tool? What do participants do? What's the one setting you'd change to make it work for YOUR group?</a:t>
+              <a:t>One pair presents their design to the room. Others play devil's advocate: 'What if the Wi-Fi dies?' 'What about the quietest young person?' 'What if someone doesn't have a phone?' The presenting pair doesn't need to solve every problem — just acknowledge it.</a:t>
             </a:r>
           </a:p>
         </p:txBody>
       </p:sp>
       <p:pic>
         <p:nvPicPr>
-          <p:cNvPr id="7" name="Picture 6" descr="logo.png"/>
+          <p:cNvPr id="6" name="Picture 5" descr="logo.png"/>
           <p:cNvPicPr>
             <a:picLocks noChangeAspect="1"/>
           </p:cNvPicPr>
@@ -8558,7 +8224,7 @@
       </p:pic>
       <p:sp>
         <p:nvSpPr>
-          <p:cNvPr id="8" name="TextBox 7"/>
+          <p:cNvPr id="7" name="TextBox 6"/>
           <p:cNvSpPr txBox="1"/>
           <p:nvPr/>
         </p:nvSpPr>
@@ -8728,7 +8394,7 @@
               </a:defRPr>
             </a:pPr>
             <a:r>
-              <a:t>Pitch Your Activity</a:t>
+              <a:t>Mix and Match</a:t>
             </a:r>
           </a:p>
         </p:txBody>
@@ -8742,21 +8408,21 @@
         <p:spPr>
           <a:xfrm>
             <a:off x="731520" y="2103120"/>
-            <a:ext cx="10515600" cy="1828800"/>
-          </a:xfrm>
-          <a:prstGeom prst="rect">
-            <a:avLst/>
-          </a:prstGeom>
-          <a:noFill/>
-        </p:spPr>
-        <p:txBody>
-          <a:bodyPr wrap="square" lIns="0" rIns="0">
-            <a:spAutoFit/>
-          </a:bodyPr>
-          <a:lstStyle/>
-          <a:p>
-            <a:pPr algn="l">
-              <a:defRPr sz="1700" b="0">
+            <a:ext cx="10515600" cy="2743200"/>
+          </a:xfrm>
+          <a:prstGeom prst="rect">
+            <a:avLst/>
+          </a:prstGeom>
+          <a:noFill/>
+        </p:spPr>
+        <p:txBody>
+          <a:bodyPr wrap="square" lIns="0" rIns="0">
+            <a:spAutoFit/>
+          </a:bodyPr>
+          <a:lstStyle/>
+          <a:p>
+            <a:pPr algn="l">
+              <a:defRPr sz="1900" b="0">
                 <a:solidFill>
                   <a:srgbClr val="FFFFFF"/>
                 </a:solidFill>
@@ -8764,7 +8430,7 @@
               </a:defRPr>
             </a:pPr>
             <a:r>
-              <a:t>Each pair gets 90 seconds to pitch their activity to another pair. No slides, no notes — just speak. The listening pair asks ONE question. Swap.</a:t>
+              <a:t>Pairs swap their design with another pair. Add one constraint: no Wi-Fi / one participant is non-verbal / half the group have no phone / there are 25 people not 10. Redesign in 10 minutes.</a:t>
             </a:r>
           </a:p>
         </p:txBody>
@@ -8965,7 +8631,7 @@
               </a:defRPr>
             </a:pPr>
             <a:r>
-              <a:t>Objection Panel</a:t>
+              <a:t>Gallery Walk</a:t>
             </a:r>
           </a:p>
         </p:txBody>
@@ -8979,21 +8645,21 @@
         <p:spPr>
           <a:xfrm>
             <a:off x="731520" y="2103120"/>
-            <a:ext cx="10515600" cy="1828800"/>
-          </a:xfrm>
-          <a:prstGeom prst="rect">
-            <a:avLst/>
-          </a:prstGeom>
-          <a:noFill/>
-        </p:spPr>
-        <p:txBody>
-          <a:bodyPr wrap="square" lIns="0" rIns="0">
-            <a:spAutoFit/>
-          </a:bodyPr>
-          <a:lstStyle/>
-          <a:p>
-            <a:pPr algn="l">
-              <a:defRPr sz="1700" b="0">
+            <a:ext cx="10515600" cy="2743200"/>
+          </a:xfrm>
+          <a:prstGeom prst="rect">
+            <a:avLst/>
+          </a:prstGeom>
+          <a:noFill/>
+        </p:spPr>
+        <p:txBody>
+          <a:bodyPr wrap="square" lIns="0" rIns="0">
+            <a:spAutoFit/>
+          </a:bodyPr>
+          <a:lstStyle/>
+          <a:p>
+            <a:pPr algn="l">
+              <a:defRPr sz="1900" b="0">
                 <a:solidFill>
                   <a:srgbClr val="FFFFFF"/>
                 </a:solidFill>
@@ -9001,7 +8667,7 @@
               </a:defRPr>
             </a:pPr>
             <a:r>
-              <a:t>One pair presents their design to the room. Others play devil's advocate: 'What if the Wi-Fi dies?' 'What about the quietest young person?' 'What if someone doesn't have a phone?' The presenting pair doesn't need to solve every problem — just acknowledge it.</a:t>
+              <a:t>Pairs pin their (now-redesigned) activity on the wall or post to a shared Padlet. Everyone walks around, reads them, and leaves one sticky note of feedback on each: 'Have you thought about…'</a:t>
             </a:r>
           </a:p>
         </p:txBody>
@@ -9080,7 +8746,7 @@
     <p:bg>
       <p:bgPr>
         <a:solidFill>
-          <a:srgbClr val="161627"/>
+          <a:srgbClr val="0D0D1A"/>
         </a:solidFill>
         <a:effectLst/>
       </p:bgPr>
@@ -9101,13 +8767,13 @@
         <p:spPr>
           <a:xfrm>
             <a:off x="0" y="0"/>
-            <a:ext cx="12191695" cy="109728"/>
+            <a:ext cx="228600" cy="6858000"/>
           </a:xfrm>
           <a:prstGeom prst="rect">
             <a:avLst/>
           </a:prstGeom>
           <a:solidFill>
-            <a:srgbClr val="FFB800"/>
+            <a:srgbClr val="00E676"/>
           </a:solidFill>
           <a:ln>
             <a:noFill/>
@@ -9143,7 +8809,7 @@
         </p:nvSpPr>
         <p:spPr>
           <a:xfrm>
-            <a:off x="731520" y="365760"/>
+            <a:off x="731520" y="411480"/>
             <a:ext cx="5486400" cy="365760"/>
           </a:xfrm>
           <a:prstGeom prst="rect">
@@ -9158,15 +8824,15 @@
           <a:lstStyle/>
           <a:p>
             <a:pPr algn="l">
-              <a:defRPr sz="1200" b="1">
-                <a:solidFill>
-                  <a:srgbClr val="FFB800"/>
-                </a:solidFill>
-                <a:latin typeface="Calibri"/>
-              </a:defRPr>
-            </a:pPr>
-            <a:r>
-              <a:t>DISCUSSION</a:t>
+              <a:defRPr sz="1400" b="1">
+                <a:solidFill>
+                  <a:srgbClr val="00E676"/>
+                </a:solidFill>
+                <a:latin typeface="Calibri"/>
+              </a:defRPr>
+            </a:pPr>
+            <a:r>
+              <a:t>CLOSING</a:t>
             </a:r>
           </a:p>
         </p:txBody>
@@ -9179,22 +8845,58 @@
         </p:nvSpPr>
         <p:spPr>
           <a:xfrm>
-            <a:off x="731520" y="914400"/>
-            <a:ext cx="10515600" cy="1097280"/>
-          </a:xfrm>
-          <a:prstGeom prst="rect">
-            <a:avLst/>
-          </a:prstGeom>
-          <a:noFill/>
-        </p:spPr>
-        <p:txBody>
-          <a:bodyPr wrap="square" lIns="0" rIns="0">
-            <a:spAutoFit/>
-          </a:bodyPr>
-          <a:lstStyle/>
-          <a:p>
-            <a:pPr algn="l">
-              <a:defRPr sz="3400" b="1">
+            <a:off x="731520" y="868680"/>
+            <a:ext cx="5486400" cy="365760"/>
+          </a:xfrm>
+          <a:prstGeom prst="rect">
+            <a:avLst/>
+          </a:prstGeom>
+          <a:noFill/>
+        </p:spPr>
+        <p:txBody>
+          <a:bodyPr wrap="square" lIns="0" rIns="0">
+            <a:spAutoFit/>
+          </a:bodyPr>
+          <a:lstStyle/>
+          <a:p>
+            <a:pPr algn="l">
+              <a:defRPr sz="1200" b="0">
+                <a:solidFill>
+                  <a:srgbClr val="7B7B96"/>
+                </a:solidFill>
+                <a:latin typeface="Calibri"/>
+              </a:defRPr>
+            </a:pPr>
+            <a:r>
+              <a:t>150 – 180 min</a:t>
+            </a:r>
+          </a:p>
+        </p:txBody>
+      </p:sp>
+      <p:sp>
+        <p:nvSpPr>
+          <p:cNvPr id="5" name="TextBox 4"/>
+          <p:cNvSpPr txBox="1"/>
+          <p:nvPr/>
+        </p:nvSpPr>
+        <p:spPr>
+          <a:xfrm>
+            <a:off x="731520" y="1828800"/>
+            <a:ext cx="10515600" cy="2286000"/>
+          </a:xfrm>
+          <a:prstGeom prst="rect">
+            <a:avLst/>
+          </a:prstGeom>
+          <a:noFill/>
+        </p:spPr>
+        <p:txBody>
+          <a:bodyPr wrap="square" lIns="0" rIns="0">
+            <a:spAutoFit/>
+          </a:bodyPr>
+          <a:lstStyle/>
+          <a:p>
+            <a:pPr algn="l">
+              <a:defRPr sz="3800" b="1">
                 <a:solidFill>
                   <a:srgbClr val="FFFFFF"/>
                 </a:solidFill>
@@ -9202,20 +8904,20 @@
               </a:defRPr>
             </a:pPr>
             <a:r>
-              <a:t>Mix and Match</a:t>
-            </a:r>
-          </a:p>
-        </p:txBody>
-      </p:sp>
-      <p:sp>
-        <p:nvSpPr>
-          <p:cNvPr id="5" name="TextBox 4"/>
-          <p:cNvSpPr txBox="1"/>
-          <p:nvPr/>
-        </p:nvSpPr>
-        <p:spPr>
-          <a:xfrm>
-            <a:off x="731520" y="2103120"/>
+              <a:t>"What practice decision did you just make — without saying a word?"</a:t>
+            </a:r>
+          </a:p>
+        </p:txBody>
+      </p:sp>
+      <p:sp>
+        <p:nvSpPr>
+          <p:cNvPr id="6" name="TextBox 5"/>
+          <p:cNvSpPr txBox="1"/>
+          <p:nvPr/>
+        </p:nvSpPr>
+        <p:spPr>
+          <a:xfrm>
+            <a:off x="731520" y="4389120"/>
             <a:ext cx="10515600" cy="1828800"/>
           </a:xfrm>
           <a:prstGeom prst="rect">
@@ -9232,41 +8934,17 @@
             <a:pPr algn="l">
               <a:defRPr sz="1700" b="0">
                 <a:solidFill>
-                  <a:srgbClr val="FFFFFF"/>
-                </a:solidFill>
-                <a:latin typeface="Calibri"/>
-              </a:defRPr>
-            </a:pPr>
-            <a:r>
-              <a:t>Pairs swap their design with another pair. Add one constraint: no Wi-Fi / one participant is non-verbal / half the group have no phone / there are 25 people not 10. Redesign in 10 minutes.</a:t>
-            </a:r>
-          </a:p>
-        </p:txBody>
-      </p:sp>
-      <p:pic>
-        <p:nvPicPr>
-          <p:cNvPr id="6" name="Picture 5" descr="logo.png"/>
-          <p:cNvPicPr>
-            <a:picLocks noChangeAspect="1"/>
-          </p:cNvPicPr>
-          <p:nvPr/>
-        </p:nvPicPr>
-        <p:blipFill>
-          <a:blip r:embed="rId2"/>
-          <a:stretch>
-            <a:fillRect/>
-          </a:stretch>
-        </p:blipFill>
-        <p:spPr>
-          <a:xfrm>
-            <a:off x="10515600" y="6355080"/>
-            <a:ext cx="1180586" cy="274320"/>
-          </a:xfrm>
-          <a:prstGeom prst="rect">
-            <a:avLst/>
-          </a:prstGeom>
-        </p:spPr>
-      </p:pic>
+                  <a:srgbClr val="B8B8D0"/>
+                </a:solidFill>
+                <a:latin typeface="Calibri"/>
+              </a:defRPr>
+            </a:pPr>
+            <a:r>
+              <a:t>Every time you set up a digital space, you're making decisions about who can speak, who can see what, and who has control. Those are youth work decisions, not tech decisions.</a:t>
+            </a:r>
+          </a:p>
+        </p:txBody>
+      </p:sp>
       <p:sp>
         <p:nvSpPr>
           <p:cNvPr id="7" name="TextBox 6"/>
@@ -9298,7 +8976,7 @@
               </a:defRPr>
             </a:pPr>
             <a:r>
-              <a:t>Session 1  ·  DISCUSSION</a:t>
+              <a:t>Robocode × LIA  ·  Digital Youth Work CPD  ·  Session 1 of 6</a:t>
             </a:r>
           </a:p>
         </p:txBody>
@@ -9344,7 +9022,7 @@
             <a:avLst/>
           </a:prstGeom>
           <a:solidFill>
-            <a:srgbClr val="FFB800"/>
+            <a:srgbClr val="00E676"/>
           </a:solidFill>
           <a:ln>
             <a:noFill/>
@@ -9397,13 +9075,13 @@
             <a:pPr algn="l">
               <a:defRPr sz="1200" b="1">
                 <a:solidFill>
-                  <a:srgbClr val="FFB800"/>
-                </a:solidFill>
-                <a:latin typeface="Calibri"/>
-              </a:defRPr>
-            </a:pPr>
-            <a:r>
-              <a:t>DISCUSSION</a:t>
+                  <a:srgbClr val="00E676"/>
+                </a:solidFill>
+                <a:latin typeface="Calibri"/>
+              </a:defRPr>
+            </a:pPr>
+            <a:r>
+              <a:t>CLOSING</a:t>
             </a:r>
           </a:p>
         </p:txBody>
@@ -9439,7 +9117,7 @@
               </a:defRPr>
             </a:pPr>
             <a:r>
-              <a:t>Gallery Walk</a:t>
+              <a:t>One Thing I'll Try</a:t>
             </a:r>
           </a:p>
         </p:txBody>
@@ -9453,21 +9131,57 @@
         <p:spPr>
           <a:xfrm>
             <a:off x="731520" y="2103120"/>
-            <a:ext cx="10515600" cy="1828800"/>
-          </a:xfrm>
-          <a:prstGeom prst="rect">
-            <a:avLst/>
-          </a:prstGeom>
-          <a:noFill/>
-        </p:spPr>
-        <p:txBody>
-          <a:bodyPr wrap="square" lIns="0" rIns="0">
-            <a:spAutoFit/>
-          </a:bodyPr>
-          <a:lstStyle/>
-          <a:p>
-            <a:pPr algn="l">
-              <a:defRPr sz="1700" b="0">
+            <a:ext cx="10515600" cy="365760"/>
+          </a:xfrm>
+          <a:prstGeom prst="rect">
+            <a:avLst/>
+          </a:prstGeom>
+          <a:noFill/>
+        </p:spPr>
+        <p:txBody>
+          <a:bodyPr wrap="square" lIns="0" rIns="0">
+            <a:spAutoFit/>
+          </a:bodyPr>
+          <a:lstStyle/>
+          <a:p>
+            <a:pPr algn="l">
+              <a:defRPr sz="1400" b="1">
+                <a:solidFill>
+                  <a:srgbClr val="E91E8C"/>
+                </a:solidFill>
+                <a:latin typeface="Calibri"/>
+              </a:defRPr>
+            </a:pPr>
+            <a:r>
+              <a:t>🛠  Mentimeter or sticky notes</a:t>
+            </a:r>
+          </a:p>
+        </p:txBody>
+      </p:sp>
+      <p:sp>
+        <p:nvSpPr>
+          <p:cNvPr id="6" name="TextBox 5"/>
+          <p:cNvSpPr txBox="1"/>
+          <p:nvPr/>
+        </p:nvSpPr>
+        <p:spPr>
+          <a:xfrm>
+            <a:off x="731520" y="2560320"/>
+            <a:ext cx="10515600" cy="2743200"/>
+          </a:xfrm>
+          <a:prstGeom prst="rect">
+            <a:avLst/>
+          </a:prstGeom>
+          <a:noFill/>
+        </p:spPr>
+        <p:txBody>
+          <a:bodyPr wrap="square" lIns="0" rIns="0">
+            <a:spAutoFit/>
+          </a:bodyPr>
+          <a:lstStyle/>
+          <a:p>
+            <a:pPr algn="l">
+              <a:defRPr sz="1900" b="0">
                 <a:solidFill>
                   <a:srgbClr val="FFFFFF"/>
                 </a:solidFill>
@@ -9475,14 +9189,14 @@
               </a:defRPr>
             </a:pPr>
             <a:r>
-              <a:t>Pairs pin their (now-redesigned) activity on the wall or post to a shared Padlet. Everyone walks around, reads them, and leaves one sticky note of feedback on each: 'Have you thought about…'</a:t>
+              <a:t>Everyone submits one thing they'll try with their group before the next session. Show results on screen. Photograph the wall.</a:t>
             </a:r>
           </a:p>
         </p:txBody>
       </p:sp>
       <p:pic>
         <p:nvPicPr>
-          <p:cNvPr id="6" name="Picture 5" descr="logo.png"/>
+          <p:cNvPr id="7" name="Picture 6" descr="logo.png"/>
           <p:cNvPicPr>
             <a:picLocks noChangeAspect="1"/>
           </p:cNvPicPr>
@@ -9506,7 +9220,7 @@
       </p:pic>
       <p:sp>
         <p:nvSpPr>
-          <p:cNvPr id="7" name="TextBox 6"/>
+          <p:cNvPr id="8" name="TextBox 7"/>
           <p:cNvSpPr txBox="1"/>
           <p:nvPr/>
         </p:nvSpPr>
@@ -9535,7 +9249,7 @@
               </a:defRPr>
             </a:pPr>
             <a:r>
-              <a:t>Session 1  ·  DISCUSSION</a:t>
+              <a:t>Session 1  ·  CLOSING</a:t>
             </a:r>
           </a:p>
         </p:txBody>
@@ -9803,7 +9517,7 @@
     <p:bg>
       <p:bgPr>
         <a:solidFill>
-          <a:srgbClr val="0D0D1A"/>
+          <a:srgbClr val="161627"/>
         </a:solidFill>
         <a:effectLst/>
       </p:bgPr>
@@ -9824,7 +9538,7 @@
         <p:spPr>
           <a:xfrm>
             <a:off x="0" y="0"/>
-            <a:ext cx="228600" cy="6858000"/>
+            <a:ext cx="12191695" cy="109728"/>
           </a:xfrm>
           <a:prstGeom prst="rect">
             <a:avLst/>
@@ -9866,7 +9580,7 @@
         </p:nvSpPr>
         <p:spPr>
           <a:xfrm>
-            <a:off x="731520" y="411480"/>
+            <a:off x="731520" y="365760"/>
             <a:ext cx="5486400" cy="365760"/>
           </a:xfrm>
           <a:prstGeom prst="rect">
@@ -9881,7 +9595,7 @@
           <a:lstStyle/>
           <a:p>
             <a:pPr algn="l">
-              <a:defRPr sz="1400" b="1">
+              <a:defRPr sz="1200" b="1">
                 <a:solidFill>
                   <a:srgbClr val="00E676"/>
                 </a:solidFill>
@@ -9902,30 +9616,30 @@
         </p:nvSpPr>
         <p:spPr>
           <a:xfrm>
-            <a:off x="731520" y="868680"/>
-            <a:ext cx="5486400" cy="365760"/>
-          </a:xfrm>
-          <a:prstGeom prst="rect">
-            <a:avLst/>
-          </a:prstGeom>
-          <a:noFill/>
-        </p:spPr>
-        <p:txBody>
-          <a:bodyPr wrap="square" lIns="0" rIns="0">
-            <a:spAutoFit/>
-          </a:bodyPr>
-          <a:lstStyle/>
-          <a:p>
-            <a:pPr algn="l">
-              <a:defRPr sz="1200" b="0">
-                <a:solidFill>
-                  <a:srgbClr val="7B7B96"/>
-                </a:solidFill>
-                <a:latin typeface="Calibri"/>
-              </a:defRPr>
-            </a:pPr>
-            <a:r>
-              <a:t>150 – 180 min</a:t>
+            <a:off x="731520" y="914400"/>
+            <a:ext cx="10515600" cy="1097280"/>
+          </a:xfrm>
+          <a:prstGeom prst="rect">
+            <a:avLst/>
+          </a:prstGeom>
+          <a:noFill/>
+        </p:spPr>
+        <p:txBody>
+          <a:bodyPr wrap="square" lIns="0" rIns="0">
+            <a:spAutoFit/>
+          </a:bodyPr>
+          <a:lstStyle/>
+          <a:p>
+            <a:pPr algn="l">
+              <a:defRPr sz="3400" b="1">
+                <a:solidFill>
+                  <a:srgbClr val="FFFFFF"/>
+                </a:solidFill>
+                <a:latin typeface="Calibri"/>
+              </a:defRPr>
+            </a:pPr>
+            <a:r>
+              <a:t>Commitment Partner</a:t>
             </a:r>
           </a:p>
         </p:txBody>
@@ -9938,22 +9652,22 @@
         </p:nvSpPr>
         <p:spPr>
           <a:xfrm>
-            <a:off x="731520" y="1828800"/>
-            <a:ext cx="10515600" cy="2286000"/>
-          </a:xfrm>
-          <a:prstGeom prst="rect">
-            <a:avLst/>
-          </a:prstGeom>
-          <a:noFill/>
-        </p:spPr>
-        <p:txBody>
-          <a:bodyPr wrap="square" lIns="0" rIns="0">
-            <a:spAutoFit/>
-          </a:bodyPr>
-          <a:lstStyle/>
-          <a:p>
-            <a:pPr algn="l">
-              <a:defRPr sz="3800" b="1">
+            <a:off x="731520" y="2103120"/>
+            <a:ext cx="10515600" cy="2743200"/>
+          </a:xfrm>
+          <a:prstGeom prst="rect">
+            <a:avLst/>
+          </a:prstGeom>
+          <a:noFill/>
+        </p:spPr>
+        <p:txBody>
+          <a:bodyPr wrap="square" lIns="0" rIns="0">
+            <a:spAutoFit/>
+          </a:bodyPr>
+          <a:lstStyle/>
+          <a:p>
+            <a:pPr algn="l">
+              <a:defRPr sz="1900" b="0">
                 <a:solidFill>
                   <a:srgbClr val="FFFFFF"/>
                 </a:solidFill>
@@ -9961,47 +9675,35 @@
               </a:defRPr>
             </a:pPr>
             <a:r>
-              <a:t>"What practice decision did you just make — without saying a word?"</a:t>
-            </a:r>
-          </a:p>
-        </p:txBody>
-      </p:sp>
-      <p:sp>
-        <p:nvSpPr>
-          <p:cNvPr id="6" name="TextBox 5"/>
-          <p:cNvSpPr txBox="1"/>
-          <p:nvPr/>
-        </p:nvSpPr>
-        <p:spPr>
-          <a:xfrm>
-            <a:off x="731520" y="4389120"/>
-            <a:ext cx="10515600" cy="1828800"/>
-          </a:xfrm>
-          <a:prstGeom prst="rect">
-            <a:avLst/>
-          </a:prstGeom>
-          <a:noFill/>
-        </p:spPr>
-        <p:txBody>
-          <a:bodyPr wrap="square" lIns="0" rIns="0">
-            <a:spAutoFit/>
-          </a:bodyPr>
-          <a:lstStyle/>
-          <a:p>
-            <a:pPr algn="l">
-              <a:defRPr sz="1700" b="0">
-                <a:solidFill>
-                  <a:srgbClr val="B8B8D0"/>
-                </a:solidFill>
-                <a:latin typeface="Calibri"/>
-              </a:defRPr>
-            </a:pPr>
-            <a:r>
-              <a:t>Every time you set up a digital space, you're making decisions about who can speak, who can see what, and who has control. Those are youth work decisions, not tech decisions.</a:t>
-            </a:r>
-          </a:p>
-        </p:txBody>
-      </p:sp>
+              <a:t>Partner with someone NOT from your organisation. Swap phone numbers. Agree one thing you'll each try and check in in 2 weeks. Put a reminder on your phone now.</a:t>
+            </a:r>
+          </a:p>
+        </p:txBody>
+      </p:sp>
+      <p:pic>
+        <p:nvPicPr>
+          <p:cNvPr id="6" name="Picture 5" descr="logo.png"/>
+          <p:cNvPicPr>
+            <a:picLocks noChangeAspect="1"/>
+          </p:cNvPicPr>
+          <p:nvPr/>
+        </p:nvPicPr>
+        <p:blipFill>
+          <a:blip r:embed="rId2"/>
+          <a:stretch>
+            <a:fillRect/>
+          </a:stretch>
+        </p:blipFill>
+        <p:spPr>
+          <a:xfrm>
+            <a:off x="10515600" y="6355080"/>
+            <a:ext cx="1180586" cy="274320"/>
+          </a:xfrm>
+          <a:prstGeom prst="rect">
+            <a:avLst/>
+          </a:prstGeom>
+        </p:spPr>
+      </p:pic>
       <p:sp>
         <p:nvSpPr>
           <p:cNvPr id="7" name="TextBox 6"/>
@@ -10033,7 +9735,7 @@
               </a:defRPr>
             </a:pPr>
             <a:r>
-              <a:t>Robocode × LIA  ·  Digital Youth Work CPD  ·  Session 1 of 6</a:t>
+              <a:t>Session 1  ·  CLOSING</a:t>
             </a:r>
           </a:p>
         </p:txBody>
@@ -10174,7 +9876,7 @@
               </a:defRPr>
             </a:pPr>
             <a:r>
-              <a:t>One Thing I'll Try</a:t>
+              <a:t>The Gap</a:t>
             </a:r>
           </a:p>
         </p:txBody>
@@ -10210,7 +9912,7 @@
               </a:defRPr>
             </a:pPr>
             <a:r>
-              <a:t>🛠  Mentimeter or sticky notes</a:t>
+              <a:t>🛠  Mentimeter</a:t>
             </a:r>
           </a:p>
         </p:txBody>
@@ -10224,21 +9926,21 @@
         <p:spPr>
           <a:xfrm>
             <a:off x="731520" y="2560320"/>
-            <a:ext cx="10515600" cy="1828800"/>
-          </a:xfrm>
-          <a:prstGeom prst="rect">
-            <a:avLst/>
-          </a:prstGeom>
-          <a:noFill/>
-        </p:spPr>
-        <p:txBody>
-          <a:bodyPr wrap="square" lIns="0" rIns="0">
-            <a:spAutoFit/>
-          </a:bodyPr>
-          <a:lstStyle/>
-          <a:p>
-            <a:pPr algn="l">
-              <a:defRPr sz="1700" b="0">
+            <a:ext cx="10515600" cy="2743200"/>
+          </a:xfrm>
+          <a:prstGeom prst="rect">
+            <a:avLst/>
+          </a:prstGeom>
+          <a:noFill/>
+        </p:spPr>
+        <p:txBody>
+          <a:bodyPr wrap="square" lIns="0" rIns="0">
+            <a:spAutoFit/>
+          </a:bodyPr>
+          <a:lstStyle/>
+          <a:p>
+            <a:pPr algn="l">
+              <a:defRPr sz="1900" b="0">
                 <a:solidFill>
                   <a:srgbClr val="FFFFFF"/>
                 </a:solidFill>
@@ -10246,7 +9948,7 @@
               </a:defRPr>
             </a:pPr>
             <a:r>
-              <a:t>Everyone submits one thing they'll try with their group before the next session. Show results on screen. Photograph the wall.</a:t>
+              <a:t>Three quick prompts on screen: 'One thing I knew before. One thing I know now. One thing I still don't know.' Submit live. Read a few aloud.</a:t>
             </a:r>
           </a:p>
         </p:txBody>
@@ -10447,7 +10149,7 @@
               </a:defRPr>
             </a:pPr>
             <a:r>
-              <a:t>Commitment Partner</a:t>
+              <a:t>Exit Ticket</a:t>
             </a:r>
           </a:p>
         </p:txBody>
@@ -10461,21 +10163,21 @@
         <p:spPr>
           <a:xfrm>
             <a:off x="731520" y="2103120"/>
-            <a:ext cx="10515600" cy="1828800"/>
-          </a:xfrm>
-          <a:prstGeom prst="rect">
-            <a:avLst/>
-          </a:prstGeom>
-          <a:noFill/>
-        </p:spPr>
-        <p:txBody>
-          <a:bodyPr wrap="square" lIns="0" rIns="0">
-            <a:spAutoFit/>
-          </a:bodyPr>
-          <a:lstStyle/>
-          <a:p>
-            <a:pPr algn="l">
-              <a:defRPr sz="1700" b="0">
+            <a:ext cx="10515600" cy="2743200"/>
+          </a:xfrm>
+          <a:prstGeom prst="rect">
+            <a:avLst/>
+          </a:prstGeom>
+          <a:noFill/>
+        </p:spPr>
+        <p:txBody>
+          <a:bodyPr wrap="square" lIns="0" rIns="0">
+            <a:spAutoFit/>
+          </a:bodyPr>
+          <a:lstStyle/>
+          <a:p>
+            <a:pPr algn="l">
+              <a:defRPr sz="1900" b="0">
                 <a:solidFill>
                   <a:srgbClr val="FFFFFF"/>
                 </a:solidFill>
@@ -10483,7 +10185,7 @@
               </a:defRPr>
             </a:pPr>
             <a:r>
-              <a:t>Partner with someone NOT from your organisation. Swap contact details. Agree one thing you'll each try and check in in 2 weeks. Write it on a card and keep it.</a:t>
+              <a:t>Sticky note on the door frame as you leave: one word that captures how you feel about running a digital activity this week. Read them back at the start of Session 2.</a:t>
             </a:r>
           </a:p>
         </p:txBody>
@@ -10557,480 +10259,6 @@
 </file>
 
 <file path=ppt/slides/slide33.xml><?xml version="1.0" encoding="utf-8"?>
-<p:sld xmlns:a="http://schemas.openxmlformats.org/drawingml/2006/main" xmlns:p="http://schemas.openxmlformats.org/presentationml/2006/main" xmlns:r="http://schemas.openxmlformats.org/officeDocument/2006/relationships">
-  <p:cSld>
-    <p:bg>
-      <p:bgPr>
-        <a:solidFill>
-          <a:srgbClr val="161627"/>
-        </a:solidFill>
-        <a:effectLst/>
-      </p:bgPr>
-    </p:bg>
-    <p:spTree>
-      <p:nvGrpSpPr>
-        <p:cNvPr id="1" name=""/>
-        <p:cNvGrpSpPr/>
-        <p:nvPr/>
-      </p:nvGrpSpPr>
-      <p:grpSpPr/>
-      <p:sp>
-        <p:nvSpPr>
-          <p:cNvPr id="2" name="Rectangle 1"/>
-          <p:cNvSpPr/>
-          <p:nvPr/>
-        </p:nvSpPr>
-        <p:spPr>
-          <a:xfrm>
-            <a:off x="0" y="0"/>
-            <a:ext cx="12191695" cy="109728"/>
-          </a:xfrm>
-          <a:prstGeom prst="rect">
-            <a:avLst/>
-          </a:prstGeom>
-          <a:solidFill>
-            <a:srgbClr val="00E676"/>
-          </a:solidFill>
-          <a:ln>
-            <a:noFill/>
-          </a:ln>
-        </p:spPr>
-        <p:style>
-          <a:lnRef idx="1">
-            <a:schemeClr val="accent1"/>
-          </a:lnRef>
-          <a:fillRef idx="3">
-            <a:schemeClr val="accent1"/>
-          </a:fillRef>
-          <a:effectRef idx="2">
-            <a:schemeClr val="accent1"/>
-          </a:effectRef>
-          <a:fontRef idx="minor">
-            <a:schemeClr val="lt1"/>
-          </a:fontRef>
-        </p:style>
-        <p:txBody>
-          <a:bodyPr rtlCol="0" anchor="ctr"/>
-          <a:lstStyle/>
-          <a:p>
-            <a:pPr algn="ctr"/>
-          </a:p>
-        </p:txBody>
-      </p:sp>
-      <p:sp>
-        <p:nvSpPr>
-          <p:cNvPr id="3" name="TextBox 2"/>
-          <p:cNvSpPr txBox="1"/>
-          <p:nvPr/>
-        </p:nvSpPr>
-        <p:spPr>
-          <a:xfrm>
-            <a:off x="731520" y="365760"/>
-            <a:ext cx="5486400" cy="365760"/>
-          </a:xfrm>
-          <a:prstGeom prst="rect">
-            <a:avLst/>
-          </a:prstGeom>
-          <a:noFill/>
-        </p:spPr>
-        <p:txBody>
-          <a:bodyPr wrap="square" lIns="0" rIns="0">
-            <a:spAutoFit/>
-          </a:bodyPr>
-          <a:lstStyle/>
-          <a:p>
-            <a:pPr algn="l">
-              <a:defRPr sz="1200" b="1">
-                <a:solidFill>
-                  <a:srgbClr val="00E676"/>
-                </a:solidFill>
-                <a:latin typeface="Calibri"/>
-              </a:defRPr>
-            </a:pPr>
-            <a:r>
-              <a:t>CLOSING</a:t>
-            </a:r>
-          </a:p>
-        </p:txBody>
-      </p:sp>
-      <p:sp>
-        <p:nvSpPr>
-          <p:cNvPr id="4" name="TextBox 3"/>
-          <p:cNvSpPr txBox="1"/>
-          <p:nvPr/>
-        </p:nvSpPr>
-        <p:spPr>
-          <a:xfrm>
-            <a:off x="731520" y="914400"/>
-            <a:ext cx="10515600" cy="1097280"/>
-          </a:xfrm>
-          <a:prstGeom prst="rect">
-            <a:avLst/>
-          </a:prstGeom>
-          <a:noFill/>
-        </p:spPr>
-        <p:txBody>
-          <a:bodyPr wrap="square" lIns="0" rIns="0">
-            <a:spAutoFit/>
-          </a:bodyPr>
-          <a:lstStyle/>
-          <a:p>
-            <a:pPr algn="l">
-              <a:defRPr sz="3400" b="1">
-                <a:solidFill>
-                  <a:srgbClr val="FFFFFF"/>
-                </a:solidFill>
-                <a:latin typeface="Calibri"/>
-              </a:defRPr>
-            </a:pPr>
-            <a:r>
-              <a:t>The Gap</a:t>
-            </a:r>
-          </a:p>
-        </p:txBody>
-      </p:sp>
-      <p:sp>
-        <p:nvSpPr>
-          <p:cNvPr id="5" name="TextBox 4"/>
-          <p:cNvSpPr txBox="1"/>
-          <p:nvPr/>
-        </p:nvSpPr>
-        <p:spPr>
-          <a:xfrm>
-            <a:off x="731520" y="2103120"/>
-            <a:ext cx="10515600" cy="1828800"/>
-          </a:xfrm>
-          <a:prstGeom prst="rect">
-            <a:avLst/>
-          </a:prstGeom>
-          <a:noFill/>
-        </p:spPr>
-        <p:txBody>
-          <a:bodyPr wrap="square" lIns="0" rIns="0">
-            <a:spAutoFit/>
-          </a:bodyPr>
-          <a:lstStyle/>
-          <a:p>
-            <a:pPr algn="l">
-              <a:defRPr sz="1700" b="0">
-                <a:solidFill>
-                  <a:srgbClr val="FFFFFF"/>
-                </a:solidFill>
-                <a:latin typeface="Calibri"/>
-              </a:defRPr>
-            </a:pPr>
-            <a:r>
-              <a:t>On a paper: 'One thing I knew before this session. One thing I know now. One thing I still don't know.' Fold it. Hand it to the facilitator on the way out.</a:t>
-            </a:r>
-          </a:p>
-        </p:txBody>
-      </p:sp>
-      <p:pic>
-        <p:nvPicPr>
-          <p:cNvPr id="6" name="Picture 5" descr="logo.png"/>
-          <p:cNvPicPr>
-            <a:picLocks noChangeAspect="1"/>
-          </p:cNvPicPr>
-          <p:nvPr/>
-        </p:nvPicPr>
-        <p:blipFill>
-          <a:blip r:embed="rId2"/>
-          <a:stretch>
-            <a:fillRect/>
-          </a:stretch>
-        </p:blipFill>
-        <p:spPr>
-          <a:xfrm>
-            <a:off x="10515600" y="6355080"/>
-            <a:ext cx="1180586" cy="274320"/>
-          </a:xfrm>
-          <a:prstGeom prst="rect">
-            <a:avLst/>
-          </a:prstGeom>
-        </p:spPr>
-      </p:pic>
-      <p:sp>
-        <p:nvSpPr>
-          <p:cNvPr id="7" name="TextBox 6"/>
-          <p:cNvSpPr txBox="1"/>
-          <p:nvPr/>
-        </p:nvSpPr>
-        <p:spPr>
-          <a:xfrm>
-            <a:off x="365760" y="6492240"/>
-            <a:ext cx="5486400" cy="274320"/>
-          </a:xfrm>
-          <a:prstGeom prst="rect">
-            <a:avLst/>
-          </a:prstGeom>
-          <a:noFill/>
-        </p:spPr>
-        <p:txBody>
-          <a:bodyPr wrap="square" lIns="0" rIns="0">
-            <a:spAutoFit/>
-          </a:bodyPr>
-          <a:lstStyle/>
-          <a:p>
-            <a:pPr algn="l">
-              <a:defRPr sz="900" b="0">
-                <a:solidFill>
-                  <a:srgbClr val="7B7B96"/>
-                </a:solidFill>
-                <a:latin typeface="Calibri"/>
-              </a:defRPr>
-            </a:pPr>
-            <a:r>
-              <a:t>Session 1  ·  CLOSING</a:t>
-            </a:r>
-          </a:p>
-        </p:txBody>
-      </p:sp>
-    </p:spTree>
-  </p:cSld>
-  <p:clrMapOvr>
-    <a:masterClrMapping/>
-  </p:clrMapOvr>
-</p:sld>
-</file>
-
-<file path=ppt/slides/slide34.xml><?xml version="1.0" encoding="utf-8"?>
-<p:sld xmlns:a="http://schemas.openxmlformats.org/drawingml/2006/main" xmlns:p="http://schemas.openxmlformats.org/presentationml/2006/main" xmlns:r="http://schemas.openxmlformats.org/officeDocument/2006/relationships">
-  <p:cSld>
-    <p:bg>
-      <p:bgPr>
-        <a:solidFill>
-          <a:srgbClr val="161627"/>
-        </a:solidFill>
-        <a:effectLst/>
-      </p:bgPr>
-    </p:bg>
-    <p:spTree>
-      <p:nvGrpSpPr>
-        <p:cNvPr id="1" name=""/>
-        <p:cNvGrpSpPr/>
-        <p:nvPr/>
-      </p:nvGrpSpPr>
-      <p:grpSpPr/>
-      <p:sp>
-        <p:nvSpPr>
-          <p:cNvPr id="2" name="Rectangle 1"/>
-          <p:cNvSpPr/>
-          <p:nvPr/>
-        </p:nvSpPr>
-        <p:spPr>
-          <a:xfrm>
-            <a:off x="0" y="0"/>
-            <a:ext cx="12191695" cy="109728"/>
-          </a:xfrm>
-          <a:prstGeom prst="rect">
-            <a:avLst/>
-          </a:prstGeom>
-          <a:solidFill>
-            <a:srgbClr val="00E676"/>
-          </a:solidFill>
-          <a:ln>
-            <a:noFill/>
-          </a:ln>
-        </p:spPr>
-        <p:style>
-          <a:lnRef idx="1">
-            <a:schemeClr val="accent1"/>
-          </a:lnRef>
-          <a:fillRef idx="3">
-            <a:schemeClr val="accent1"/>
-          </a:fillRef>
-          <a:effectRef idx="2">
-            <a:schemeClr val="accent1"/>
-          </a:effectRef>
-          <a:fontRef idx="minor">
-            <a:schemeClr val="lt1"/>
-          </a:fontRef>
-        </p:style>
-        <p:txBody>
-          <a:bodyPr rtlCol="0" anchor="ctr"/>
-          <a:lstStyle/>
-          <a:p>
-            <a:pPr algn="ctr"/>
-          </a:p>
-        </p:txBody>
-      </p:sp>
-      <p:sp>
-        <p:nvSpPr>
-          <p:cNvPr id="3" name="TextBox 2"/>
-          <p:cNvSpPr txBox="1"/>
-          <p:nvPr/>
-        </p:nvSpPr>
-        <p:spPr>
-          <a:xfrm>
-            <a:off x="731520" y="365760"/>
-            <a:ext cx="5486400" cy="365760"/>
-          </a:xfrm>
-          <a:prstGeom prst="rect">
-            <a:avLst/>
-          </a:prstGeom>
-          <a:noFill/>
-        </p:spPr>
-        <p:txBody>
-          <a:bodyPr wrap="square" lIns="0" rIns="0">
-            <a:spAutoFit/>
-          </a:bodyPr>
-          <a:lstStyle/>
-          <a:p>
-            <a:pPr algn="l">
-              <a:defRPr sz="1200" b="1">
-                <a:solidFill>
-                  <a:srgbClr val="00E676"/>
-                </a:solidFill>
-                <a:latin typeface="Calibri"/>
-              </a:defRPr>
-            </a:pPr>
-            <a:r>
-              <a:t>CLOSING</a:t>
-            </a:r>
-          </a:p>
-        </p:txBody>
-      </p:sp>
-      <p:sp>
-        <p:nvSpPr>
-          <p:cNvPr id="4" name="TextBox 3"/>
-          <p:cNvSpPr txBox="1"/>
-          <p:nvPr/>
-        </p:nvSpPr>
-        <p:spPr>
-          <a:xfrm>
-            <a:off x="731520" y="914400"/>
-            <a:ext cx="10515600" cy="1097280"/>
-          </a:xfrm>
-          <a:prstGeom prst="rect">
-            <a:avLst/>
-          </a:prstGeom>
-          <a:noFill/>
-        </p:spPr>
-        <p:txBody>
-          <a:bodyPr wrap="square" lIns="0" rIns="0">
-            <a:spAutoFit/>
-          </a:bodyPr>
-          <a:lstStyle/>
-          <a:p>
-            <a:pPr algn="l">
-              <a:defRPr sz="3400" b="1">
-                <a:solidFill>
-                  <a:srgbClr val="FFFFFF"/>
-                </a:solidFill>
-                <a:latin typeface="Calibri"/>
-              </a:defRPr>
-            </a:pPr>
-            <a:r>
-              <a:t>Exit Ticket</a:t>
-            </a:r>
-          </a:p>
-        </p:txBody>
-      </p:sp>
-      <p:sp>
-        <p:nvSpPr>
-          <p:cNvPr id="5" name="TextBox 4"/>
-          <p:cNvSpPr txBox="1"/>
-          <p:nvPr/>
-        </p:nvSpPr>
-        <p:spPr>
-          <a:xfrm>
-            <a:off x="731520" y="2103120"/>
-            <a:ext cx="10515600" cy="1828800"/>
-          </a:xfrm>
-          <a:prstGeom prst="rect">
-            <a:avLst/>
-          </a:prstGeom>
-          <a:noFill/>
-        </p:spPr>
-        <p:txBody>
-          <a:bodyPr wrap="square" lIns="0" rIns="0">
-            <a:spAutoFit/>
-          </a:bodyPr>
-          <a:lstStyle/>
-          <a:p>
-            <a:pPr algn="l">
-              <a:defRPr sz="1700" b="0">
-                <a:solidFill>
-                  <a:srgbClr val="FFFFFF"/>
-                </a:solidFill>
-                <a:latin typeface="Calibri"/>
-              </a:defRPr>
-            </a:pPr>
-            <a:r>
-              <a:t>Sticky note on the door frame as you leave: one word that captures how you feel about running a digital activity this week. Read them back at the start of Session 2.</a:t>
-            </a:r>
-          </a:p>
-        </p:txBody>
-      </p:sp>
-      <p:pic>
-        <p:nvPicPr>
-          <p:cNvPr id="6" name="Picture 5" descr="logo.png"/>
-          <p:cNvPicPr>
-            <a:picLocks noChangeAspect="1"/>
-          </p:cNvPicPr>
-          <p:nvPr/>
-        </p:nvPicPr>
-        <p:blipFill>
-          <a:blip r:embed="rId2"/>
-          <a:stretch>
-            <a:fillRect/>
-          </a:stretch>
-        </p:blipFill>
-        <p:spPr>
-          <a:xfrm>
-            <a:off x="10515600" y="6355080"/>
-            <a:ext cx="1180586" cy="274320"/>
-          </a:xfrm>
-          <a:prstGeom prst="rect">
-            <a:avLst/>
-          </a:prstGeom>
-        </p:spPr>
-      </p:pic>
-      <p:sp>
-        <p:nvSpPr>
-          <p:cNvPr id="7" name="TextBox 6"/>
-          <p:cNvSpPr txBox="1"/>
-          <p:nvPr/>
-        </p:nvSpPr>
-        <p:spPr>
-          <a:xfrm>
-            <a:off x="365760" y="6492240"/>
-            <a:ext cx="5486400" cy="274320"/>
-          </a:xfrm>
-          <a:prstGeom prst="rect">
-            <a:avLst/>
-          </a:prstGeom>
-          <a:noFill/>
-        </p:spPr>
-        <p:txBody>
-          <a:bodyPr wrap="square" lIns="0" rIns="0">
-            <a:spAutoFit/>
-          </a:bodyPr>
-          <a:lstStyle/>
-          <a:p>
-            <a:pPr algn="l">
-              <a:defRPr sz="900" b="0">
-                <a:solidFill>
-                  <a:srgbClr val="7B7B96"/>
-                </a:solidFill>
-                <a:latin typeface="Calibri"/>
-              </a:defRPr>
-            </a:pPr>
-            <a:r>
-              <a:t>Session 1  ·  CLOSING</a:t>
-            </a:r>
-          </a:p>
-        </p:txBody>
-      </p:sp>
-    </p:spTree>
-  </p:cSld>
-  <p:clrMapOvr>
-    <a:masterClrMapping/>
-  </p:clrMapOvr>
-</p:sld>
-</file>
-
-<file path=ppt/slides/slide35.xml><?xml version="1.0" encoding="utf-8"?>
 <p:sld xmlns:a="http://schemas.openxmlformats.org/drawingml/2006/main" xmlns:p="http://schemas.openxmlformats.org/presentationml/2006/main" xmlns:r="http://schemas.openxmlformats.org/officeDocument/2006/relationships">
   <p:cSld>
     <p:bg>
@@ -11495,21 +10723,21 @@
         <p:spPr>
           <a:xfrm>
             <a:off x="731520" y="2103120"/>
-            <a:ext cx="10515600" cy="1828800"/>
-          </a:xfrm>
-          <a:prstGeom prst="rect">
-            <a:avLst/>
-          </a:prstGeom>
-          <a:noFill/>
-        </p:spPr>
-        <p:txBody>
-          <a:bodyPr wrap="square" lIns="0" rIns="0">
-            <a:spAutoFit/>
-          </a:bodyPr>
-          <a:lstStyle/>
-          <a:p>
-            <a:pPr algn="l">
-              <a:defRPr sz="1700" b="0">
+            <a:ext cx="10515600" cy="2743200"/>
+          </a:xfrm>
+          <a:prstGeom prst="rect">
+            <a:avLst/>
+          </a:prstGeom>
+          <a:noFill/>
+        </p:spPr>
+        <p:txBody>
+          <a:bodyPr wrap="square" lIns="0" rIns="0">
+            <a:spAutoFit/>
+          </a:bodyPr>
+          <a:lstStyle/>
+          <a:p>
+            <a:pPr algn="l">
+              <a:defRPr sz="1900" b="0">
                 <a:solidFill>
                   <a:srgbClr val="FFFFFF"/>
                 </a:solidFill>
@@ -11768,21 +10996,21 @@
         <p:spPr>
           <a:xfrm>
             <a:off x="731520" y="2560320"/>
-            <a:ext cx="10515600" cy="1828800"/>
-          </a:xfrm>
-          <a:prstGeom prst="rect">
-            <a:avLst/>
-          </a:prstGeom>
-          <a:noFill/>
-        </p:spPr>
-        <p:txBody>
-          <a:bodyPr wrap="square" lIns="0" rIns="0">
-            <a:spAutoFit/>
-          </a:bodyPr>
-          <a:lstStyle/>
-          <a:p>
-            <a:pPr algn="l">
-              <a:defRPr sz="1700" b="0">
+            <a:ext cx="10515600" cy="2743200"/>
+          </a:xfrm>
+          <a:prstGeom prst="rect">
+            <a:avLst/>
+          </a:prstGeom>
+          <a:noFill/>
+        </p:spPr>
+        <p:txBody>
+          <a:bodyPr wrap="square" lIns="0" rIns="0">
+            <a:spAutoFit/>
+          </a:bodyPr>
+          <a:lstStyle/>
+          <a:p>
+            <a:pPr algn="l">
+              <a:defRPr sz="1900" b="0">
                 <a:solidFill>
                   <a:srgbClr val="FFFFFF"/>
                 </a:solidFill>
@@ -12005,21 +11233,21 @@
         <p:spPr>
           <a:xfrm>
             <a:off x="731520" y="2103120"/>
-            <a:ext cx="10515600" cy="1828800"/>
-          </a:xfrm>
-          <a:prstGeom prst="rect">
-            <a:avLst/>
-          </a:prstGeom>
-          <a:noFill/>
-        </p:spPr>
-        <p:txBody>
-          <a:bodyPr wrap="square" lIns="0" rIns="0">
-            <a:spAutoFit/>
-          </a:bodyPr>
-          <a:lstStyle/>
-          <a:p>
-            <a:pPr algn="l">
-              <a:defRPr sz="1700" b="0">
+            <a:ext cx="10515600" cy="2743200"/>
+          </a:xfrm>
+          <a:prstGeom prst="rect">
+            <a:avLst/>
+          </a:prstGeom>
+          <a:noFill/>
+        </p:spPr>
+        <p:txBody>
+          <a:bodyPr wrap="square" lIns="0" rIns="0">
+            <a:spAutoFit/>
+          </a:bodyPr>
+          <a:lstStyle/>
+          <a:p>
+            <a:pPr algn="l">
+              <a:defRPr sz="1900" b="0">
                 <a:solidFill>
                   <a:srgbClr val="FFFFFF"/>
                 </a:solidFill>
@@ -12242,21 +11470,21 @@
         <p:spPr>
           <a:xfrm>
             <a:off x="731520" y="2103120"/>
-            <a:ext cx="10515600" cy="1828800"/>
-          </a:xfrm>
-          <a:prstGeom prst="rect">
-            <a:avLst/>
-          </a:prstGeom>
-          <a:noFill/>
-        </p:spPr>
-        <p:txBody>
-          <a:bodyPr wrap="square" lIns="0" rIns="0">
-            <a:spAutoFit/>
-          </a:bodyPr>
-          <a:lstStyle/>
-          <a:p>
-            <a:pPr algn="l">
-              <a:defRPr sz="1700" b="0">
+            <a:ext cx="10515600" cy="2743200"/>
+          </a:xfrm>
+          <a:prstGeom prst="rect">
+            <a:avLst/>
+          </a:prstGeom>
+          <a:noFill/>
+        </p:spPr>
+        <p:txBody>
+          <a:bodyPr wrap="square" lIns="0" rIns="0">
+            <a:spAutoFit/>
+          </a:bodyPr>
+          <a:lstStyle/>
+          <a:p>
+            <a:pPr algn="l">
+              <a:defRPr sz="1900" b="0">
                 <a:solidFill>
                   <a:srgbClr val="FFFFFF"/>
                 </a:solidFill>
@@ -12264,137 +11492,14 @@
               </a:defRPr>
             </a:pPr>
             <a:r>
-              <a:t>Facilitator reads 4 statements. Participants move to the Yes, No, or Maybe corner of the room. Keep it quick — don't debate, just move.</a:t>
-            </a:r>
-          </a:p>
-        </p:txBody>
-      </p:sp>
-      <p:sp>
-        <p:nvSpPr>
-          <p:cNvPr id="6" name="TextBox 5"/>
-          <p:cNvSpPr txBox="1"/>
-          <p:nvPr/>
-        </p:nvSpPr>
-        <p:spPr>
-          <a:xfrm>
-            <a:off x="731520" y="3566160"/>
-            <a:ext cx="10515600" cy="365760"/>
-          </a:xfrm>
-          <a:prstGeom prst="rect">
-            <a:avLst/>
-          </a:prstGeom>
-          <a:noFill/>
-        </p:spPr>
-        <p:txBody>
-          <a:bodyPr wrap="square" lIns="0" rIns="0">
-            <a:spAutoFit/>
-          </a:bodyPr>
-          <a:lstStyle/>
-          <a:p>
-            <a:pPr algn="l">
-              <a:defRPr sz="1300" b="1">
-                <a:solidFill>
-                  <a:srgbClr val="7B61FF"/>
-                </a:solidFill>
-                <a:latin typeface="Calibri"/>
-              </a:defRPr>
-            </a:pPr>
-            <a:r>
-              <a:t>Examples:</a:t>
-            </a:r>
-          </a:p>
-        </p:txBody>
-      </p:sp>
-      <p:sp>
-        <p:nvSpPr>
-          <p:cNvPr id="7" name="TextBox 6"/>
-          <p:cNvSpPr txBox="1"/>
-          <p:nvPr/>
-        </p:nvSpPr>
-        <p:spPr>
-          <a:xfrm>
-            <a:off x="731520" y="3931920"/>
-            <a:ext cx="10515600" cy="2743200"/>
-          </a:xfrm>
-          <a:prstGeom prst="rect">
-            <a:avLst/>
-          </a:prstGeom>
-          <a:noFill/>
-        </p:spPr>
-        <p:txBody>
-          <a:bodyPr wrap="square" lIns="0">
-            <a:spAutoFit/>
-          </a:bodyPr>
-          <a:lstStyle/>
-          <a:p>
-            <a:pPr>
-              <a:spcAft>
-                <a:spcPts val="800"/>
-              </a:spcAft>
-              <a:defRPr sz="1300">
-                <a:solidFill>
-                  <a:srgbClr val="B8B8D0"/>
-                </a:solidFill>
-                <a:latin typeface="Calibri"/>
-              </a:defRPr>
-            </a:pPr>
-            <a:r>
-              <a:t>•  I'd be comfortable running a Zoom session with young people tomorrow</a:t>
-            </a:r>
-          </a:p>
-          <a:p>
-            <a:pPr>
-              <a:spcAft>
-                <a:spcPts val="800"/>
-              </a:spcAft>
-              <a:defRPr sz="1300">
-                <a:solidFill>
-                  <a:srgbClr val="B8B8D0"/>
-                </a:solidFill>
-                <a:latin typeface="Calibri"/>
-              </a:defRPr>
-            </a:pPr>
-            <a:r>
-              <a:t>•  My organisation has a digital strategy I actually understand</a:t>
-            </a:r>
-          </a:p>
-          <a:p>
-            <a:pPr>
-              <a:spcAft>
-                <a:spcPts val="800"/>
-              </a:spcAft>
-              <a:defRPr sz="1300">
-                <a:solidFill>
-                  <a:srgbClr val="B8B8D0"/>
-                </a:solidFill>
-                <a:latin typeface="Calibri"/>
-              </a:defRPr>
-            </a:pPr>
-            <a:r>
-              <a:t>•  I know which platform my young people use most</a:t>
-            </a:r>
-          </a:p>
-          <a:p>
-            <a:pPr>
-              <a:spcAft>
-                <a:spcPts val="800"/>
-              </a:spcAft>
-              <a:defRPr sz="1300">
-                <a:solidFill>
-                  <a:srgbClr val="B8B8D0"/>
-                </a:solidFill>
-                <a:latin typeface="Calibri"/>
-              </a:defRPr>
-            </a:pPr>
-            <a:r>
-              <a:t>•  Digital youth work is something we do properly, not just a backup</a:t>
+              <a:t>Four statements will be read out. Move to the Yes, No, or Maybe corner of the room for each. Keep it quick — don't debate, just move.</a:t>
             </a:r>
           </a:p>
         </p:txBody>
       </p:sp>
       <p:pic>
         <p:nvPicPr>
-          <p:cNvPr id="8" name="Picture 7" descr="logo.png"/>
+          <p:cNvPr id="6" name="Picture 5" descr="logo.png"/>
           <p:cNvPicPr>
             <a:picLocks noChangeAspect="1"/>
           </p:cNvPicPr>
@@ -12418,7 +11523,7 @@
       </p:pic>
       <p:sp>
         <p:nvSpPr>
-          <p:cNvPr id="9" name="TextBox 8"/>
+          <p:cNvPr id="7" name="TextBox 6"/>
           <p:cNvSpPr txBox="1"/>
           <p:nvPr/>
         </p:nvSpPr>
@@ -12602,21 +11707,21 @@
         <p:spPr>
           <a:xfrm>
             <a:off x="731520" y="2103120"/>
-            <a:ext cx="10515600" cy="1828800"/>
-          </a:xfrm>
-          <a:prstGeom prst="rect">
-            <a:avLst/>
-          </a:prstGeom>
-          <a:noFill/>
-        </p:spPr>
-        <p:txBody>
-          <a:bodyPr wrap="square" lIns="0" rIns="0">
-            <a:spAutoFit/>
-          </a:bodyPr>
-          <a:lstStyle/>
-          <a:p>
-            <a:pPr algn="l">
-              <a:defRPr sz="1700" b="0">
+            <a:ext cx="10515600" cy="2743200"/>
+          </a:xfrm>
+          <a:prstGeom prst="rect">
+            <a:avLst/>
+          </a:prstGeom>
+          <a:noFill/>
+        </p:spPr>
+        <p:txBody>
+          <a:bodyPr wrap="square" lIns="0" rIns="0">
+            <a:spAutoFit/>
+          </a:bodyPr>
+          <a:lstStyle/>
+          <a:p>
+            <a:pPr algn="l">
+              <a:defRPr sz="1900" b="0">
                 <a:solidFill>
                   <a:srgbClr val="FFFFFF"/>
                 </a:solidFill>
@@ -12897,7 +12002,7 @@
               </a:defRPr>
             </a:pPr>
             <a:r>
-              <a:t>8 activities in this block:</a:t>
+              <a:t>6 activities in this block:</a:t>
             </a:r>
           </a:p>
         </p:txBody>
@@ -12952,7 +12057,7 @@
               </a:defRPr>
             </a:pPr>
             <a:r>
-              <a:t>→  Observer Round</a:t>
+              <a:t>→  What Just Happened?</a:t>
             </a:r>
           </a:p>
           <a:p>
@@ -12968,7 +12073,7 @@
               </a:defRPr>
             </a:pPr>
             <a:r>
-              <a:t>→  What Just Happened?</a:t>
+              <a:t>→  Change One Thing</a:t>
             </a:r>
           </a:p>
           <a:p>
@@ -12984,7 +12089,7 @@
               </a:defRPr>
             </a:pPr>
             <a:r>
-              <a:t>→  Change One Thing</a:t>
+              <a:t>→  The Anonymous Round</a:t>
             </a:r>
           </a:p>
           <a:p>
@@ -13000,39 +12105,7 @@
               </a:defRPr>
             </a:pPr>
             <a:r>
-              <a:t>→  The Anonymous Round</a:t>
-            </a:r>
-          </a:p>
-          <a:p>
-            <a:pPr>
-              <a:spcAft>
-                <a:spcPts val="800"/>
-              </a:spcAft>
-              <a:defRPr sz="1600">
-                <a:solidFill>
-                  <a:srgbClr val="FFFFFF"/>
-                </a:solidFill>
-                <a:latin typeface="Calibri"/>
-              </a:defRPr>
-            </a:pPr>
-            <a:r>
-              <a:t>→  Settings Gallery</a:t>
-            </a:r>
-          </a:p>
-          <a:p>
-            <a:pPr>
-              <a:spcAft>
-                <a:spcPts val="800"/>
-              </a:spcAft>
-              <a:defRPr sz="1600">
-                <a:solidFill>
-                  <a:srgbClr val="FFFFFF"/>
-                </a:solidFill>
-                <a:latin typeface="Calibri"/>
-              </a:defRPr>
-            </a:pPr>
-            <a:r>
-              <a:t>→  Design Decision Cards</a:t>
+              <a:t>→  Sticky Note Audit</a:t>
             </a:r>
           </a:p>
           <a:p>

</xml_diff>

<commit_message>
Update session opening questions per curriculum update
S1: 'What happens when young people engage in digital spaces?'
S2: 'What are the hidden and explicit values of the digital youth work curriculum?'
S3: 'What is harm in digital spaces — and where does it show up, online and in-person?'
S6: 'What does good digital youth work look like?' (drop 'actually')

Co-Authored-By: Claude Opus 4.6 <noreply@anthropic.com>
</commit_message>
<xml_diff>
--- a/assets/downloads/Session-1-What-Is-Digital-Youth-Work.pptx
+++ b/assets/downloads/Session-1-What-Is-Digital-Youth-Work.pptx
@@ -9426,7 +9426,7 @@
               </a:defRPr>
             </a:pPr>
             <a:r>
-              <a:t>"How does youth work change when young people are online?"</a:t>
+              <a:t>"What happens when young people engage in digital spaces?"</a:t>
             </a:r>
           </a:p>
         </p:txBody>
@@ -9462,7 +9462,7 @@
               </a:defRPr>
             </a:pPr>
             <a:r>
-              <a:t>This isn't about technology. It's about whether the things you already do as a youth worker — building trust, giving young people a voice, keeping them safe — work the same way on a screen.</a:t>
+              <a:t>Young people live, play, argue, hide, perform and grow in digital spaces. Youth work doesn't pause at the screen — it follows them there. This session is about what that actually looks like, and what changes about the work when it does.</a:t>
             </a:r>
           </a:p>
         </p:txBody>

</xml_diff>